<commit_message>
Redesign workshop deck with larger type and row layout
Condensed to nine slides and rebuilt the lab and documentation slides as
numbered rows with hairline dividers instead of long paragraphs. Raised the
type scale throughout, aligned accent colors to each track (cobalt for VS
Code, coral for the Copilot app), and fixed Calibri fallbacks to Aptos.

Co-authored-by: Copilot App <223556219+Copilot@users.noreply.github.com>
</commit_message>
<xml_diff>
--- a/NDC-Oslo-Copilot-Workshop.pptx
+++ b/NDC-Oslo-Copilot-Workshop.pptx
@@ -3601,20 +3601,20 @@
         <p:spPr>
           <a:xfrm>
             <a:off x="731520" y="548640"/>
-            <a:ext cx="4206240" cy="274320"/>
-          </a:xfrm>
-          <a:prstGeom prst="rect">
-            <a:avLst/>
-          </a:prstGeom>
-        </p:spPr>
-        <p:txBody>
-          <a:bodyPr wrap="square" rtlCol="0">
-            <a:spAutoFit/>
-          </a:bodyPr>
-          <a:lstStyle/>
-          <a:p>
-            <a:r>
-              <a:rPr b="1" sz="1300" spc="120">
+            <a:ext cx="4572000" cy="310896"/>
+          </a:xfrm>
+          <a:prstGeom prst="rect">
+            <a:avLst/>
+          </a:prstGeom>
+        </p:spPr>
+        <p:txBody>
+          <a:bodyPr wrap="square" rtlCol="0">
+            <a:spAutoFit/>
+          </a:bodyPr>
+          <a:lstStyle/>
+          <a:p>
+            <a:r>
+              <a:rPr b="1" sz="1500" spc="260">
                 <a:solidFill>
                   <a:srgbClr val="1746D1"/>
                 </a:solidFill>
@@ -3633,21 +3633,21 @@
         </p:nvSpPr>
         <p:spPr>
           <a:xfrm>
-            <a:off x="731520" y="1371600"/>
-            <a:ext cx="4206240" cy="1737360"/>
-          </a:xfrm>
-          <a:prstGeom prst="rect">
-            <a:avLst/>
-          </a:prstGeom>
-        </p:spPr>
-        <p:txBody>
-          <a:bodyPr wrap="square" rtlCol="0">
-            <a:spAutoFit/>
-          </a:bodyPr>
-          <a:lstStyle/>
-          <a:p>
-            <a:r>
-              <a:rPr b="1" sz="4200" spc="-100">
+            <a:off x="731520" y="1280160"/>
+            <a:ext cx="4572000" cy="1828800"/>
+          </a:xfrm>
+          <a:prstGeom prst="rect">
+            <a:avLst/>
+          </a:prstGeom>
+        </p:spPr>
+        <p:txBody>
+          <a:bodyPr wrap="square" rtlCol="0">
+            <a:spAutoFit/>
+          </a:bodyPr>
+          <a:lstStyle/>
+          <a:p>
+            <a:r>
+              <a:rPr b="1" sz="5000" spc="-100">
                 <a:solidFill>
                   <a:srgbClr val="172033"/>
                 </a:solidFill>
@@ -3658,7 +3658,7 @@
           </a:p>
           <a:p>
             <a:r>
-              <a:rPr b="1" sz="4200" spc="-100">
+              <a:rPr b="1" sz="5000" spc="-100">
                 <a:solidFill>
                   <a:srgbClr val="1746D1"/>
                 </a:solidFill>
@@ -3677,38 +3677,38 @@
         </p:nvSpPr>
         <p:spPr>
           <a:xfrm>
-            <a:off x="731520" y="3429000"/>
-            <a:ext cx="4206240" cy="914400"/>
-          </a:xfrm>
-          <a:prstGeom prst="rect">
-            <a:avLst/>
-          </a:prstGeom>
-        </p:spPr>
-        <p:txBody>
-          <a:bodyPr wrap="square" rtlCol="0">
-            <a:spAutoFit/>
-          </a:bodyPr>
-          <a:lstStyle/>
-          <a:p>
-            <a:r>
-              <a:rPr sz="2000">
-                <a:solidFill>
-                  <a:srgbClr val="5A6578"/>
-                </a:solidFill>
-                <a:latin typeface="Aptos"/>
-              </a:rPr>
-              <a:t>Two tracks. One agentic development journey.</a:t>
-            </a:r>
-          </a:p>
-          <a:p>
-            <a:r>
-              <a:rPr sz="2000">
-                <a:solidFill>
-                  <a:srgbClr val="5A6578"/>
-                </a:solidFill>
-                <a:latin typeface="Aptos"/>
-              </a:rPr>
-              <a:t>Start in VS Code, then move to the GitHub Copilot app.</a:t>
+            <a:off x="731520" y="3520440"/>
+            <a:ext cx="4572000" cy="1188720"/>
+          </a:xfrm>
+          <a:prstGeom prst="rect">
+            <a:avLst/>
+          </a:prstGeom>
+        </p:spPr>
+        <p:txBody>
+          <a:bodyPr wrap="square" rtlCol="0">
+            <a:spAutoFit/>
+          </a:bodyPr>
+          <a:lstStyle/>
+          <a:p>
+            <a:r>
+              <a:rPr sz="2100">
+                <a:solidFill>
+                  <a:srgbClr val="455166"/>
+                </a:solidFill>
+                <a:latin typeface="Aptos"/>
+              </a:rPr>
+              <a:t>Two tracks. One agentic journey.</a:t>
+            </a:r>
+          </a:p>
+          <a:p>
+            <a:r>
+              <a:rPr sz="2100">
+                <a:solidFill>
+                  <a:srgbClr val="455166"/>
+                </a:solidFill>
+                <a:latin typeface="Aptos"/>
+              </a:rPr>
+              <a:t>VS Code first, then the Copilot app.</a:t>
             </a:r>
           </a:p>
         </p:txBody>
@@ -3722,20 +3722,20 @@
         <p:spPr>
           <a:xfrm>
             <a:off x="731520" y="5486400"/>
-            <a:ext cx="4206240" cy="548640"/>
-          </a:xfrm>
-          <a:prstGeom prst="rect">
-            <a:avLst/>
-          </a:prstGeom>
-        </p:spPr>
-        <p:txBody>
-          <a:bodyPr wrap="square" rtlCol="0">
-            <a:spAutoFit/>
-          </a:bodyPr>
-          <a:lstStyle/>
-          <a:p>
-            <a:r>
-              <a:rPr b="1" sz="1400">
+            <a:ext cx="4572000" cy="320040"/>
+          </a:xfrm>
+          <a:prstGeom prst="rect">
+            <a:avLst/>
+          </a:prstGeom>
+        </p:spPr>
+        <p:txBody>
+          <a:bodyPr wrap="square" rtlCol="0">
+            <a:spAutoFit/>
+          </a:bodyPr>
+          <a:lstStyle/>
+          <a:p>
+            <a:r>
+              <a:rPr b="1" sz="1700" spc="80">
                 <a:solidFill>
                   <a:srgbClr val="172033"/>
                 </a:solidFill>
@@ -3768,11 +3768,11 @@
           <a:lstStyle/>
           <a:p>
             <a:r>
-              <a:rPr b="1" sz="2400">
+              <a:rPr b="1" sz="2400" spc="80">
                 <a:solidFill>
                   <a:srgbClr val="F8FAFC"/>
                 </a:solidFill>
-                <a:latin typeface="Aptos Display"/>
+                <a:latin typeface="Aptos"/>
               </a:rPr>
               <a:t>01  VS CODE</a:t>
             </a:r>
@@ -3801,11 +3801,11 @@
           <a:lstStyle/>
           <a:p>
             <a:r>
-              <a:rPr b="1" sz="2400">
+              <a:rPr b="1" sz="2400" spc="80">
                 <a:solidFill>
                   <a:srgbClr val="F8FAFC"/>
                 </a:solidFill>
-                <a:latin typeface="Aptos Display"/>
+                <a:latin typeface="Aptos"/>
               </a:rPr>
               <a:t>02  COPILOT APP</a:t>
             </a:r>
@@ -3834,13 +3834,13 @@
           <a:lstStyle/>
           <a:p>
             <a:r>
-              <a:rPr b="1" sz="1100" spc="110">
+              <a:rPr b="1" sz="1300" spc="160">
                 <a:solidFill>
                   <a:srgbClr val="C9D8FF"/>
                 </a:solidFill>
                 <a:latin typeface="Aptos"/>
               </a:rPr>
-              <a:t>TWO CONNECTED WORK SURFACES</a:t>
+              <a:t>TWO WORK SURFACES</a:t>
             </a:r>
           </a:p>
         </p:txBody>
@@ -3853,21 +3853,21 @@
         </p:nvSpPr>
         <p:spPr>
           <a:xfrm>
-            <a:off x="731520" y="6309360"/>
-            <a:ext cx="4206240" cy="274320"/>
-          </a:xfrm>
-          <a:prstGeom prst="rect">
-            <a:avLst/>
-          </a:prstGeom>
-        </p:spPr>
-        <p:txBody>
-          <a:bodyPr wrap="square" rtlCol="0">
-            <a:spAutoFit/>
-          </a:bodyPr>
-          <a:lstStyle/>
-          <a:p>
-            <a:r>
-              <a:rPr b="1" sz="1400">
+            <a:off x="731520" y="6255552"/>
+            <a:ext cx="4572000" cy="320040"/>
+          </a:xfrm>
+          <a:prstGeom prst="rect">
+            <a:avLst/>
+          </a:prstGeom>
+        </p:spPr>
+        <p:txBody>
+          <a:bodyPr wrap="square" rtlCol="0">
+            <a:spAutoFit/>
+          </a:bodyPr>
+          <a:lstStyle/>
+          <a:p>
+            <a:r>
+              <a:rPr b="1" sz="1700">
                 <a:solidFill>
                   <a:srgbClr val="1746D1"/>
                 </a:solidFill>
@@ -4909,21 +4909,21 @@
         </p:nvSpPr>
         <p:spPr>
           <a:xfrm>
-            <a:off x="960120" y="365760"/>
-            <a:ext cx="5486400" cy="274320"/>
-          </a:xfrm>
-          <a:prstGeom prst="rect">
-            <a:avLst/>
-          </a:prstGeom>
-        </p:spPr>
-        <p:txBody>
-          <a:bodyPr wrap="square" rtlCol="0">
-            <a:spAutoFit/>
-          </a:bodyPr>
-          <a:lstStyle/>
-          <a:p>
-            <a:r>
-              <a:rPr b="1" sz="1200" spc="120">
+            <a:off x="960120" y="347472"/>
+            <a:ext cx="6858000" cy="310896"/>
+          </a:xfrm>
+          <a:prstGeom prst="rect">
+            <a:avLst/>
+          </a:prstGeom>
+        </p:spPr>
+        <p:txBody>
+          <a:bodyPr wrap="square" rtlCol="0">
+            <a:spAutoFit/>
+          </a:bodyPr>
+          <a:lstStyle/>
+          <a:p>
+            <a:r>
+              <a:rPr b="1" sz="1500" spc="240">
                 <a:solidFill>
                   <a:srgbClr val="1746D1"/>
                 </a:solidFill>
@@ -4942,21 +4942,21 @@
         </p:nvSpPr>
         <p:spPr>
           <a:xfrm>
-            <a:off x="685800" y="868680"/>
-            <a:ext cx="7772400" cy="1005840"/>
-          </a:xfrm>
-          <a:prstGeom prst="rect">
-            <a:avLst/>
-          </a:prstGeom>
-        </p:spPr>
-        <p:txBody>
-          <a:bodyPr wrap="square" rtlCol="0">
-            <a:spAutoFit/>
-          </a:bodyPr>
-          <a:lstStyle/>
-          <a:p>
-            <a:r>
-              <a:rPr b="1" sz="3400" spc="-80">
+            <a:off x="685800" y="754380"/>
+            <a:ext cx="7772400" cy="1188720"/>
+          </a:xfrm>
+          <a:prstGeom prst="rect">
+            <a:avLst/>
+          </a:prstGeom>
+        </p:spPr>
+        <p:txBody>
+          <a:bodyPr wrap="square" rtlCol="0">
+            <a:spAutoFit/>
+          </a:bodyPr>
+          <a:lstStyle/>
+          <a:p>
+            <a:r>
+              <a:rPr b="1" sz="4200" spc="-60">
                 <a:solidFill>
                   <a:srgbClr val="172033"/>
                 </a:solidFill>
@@ -4975,18 +4975,29 @@
         </p:nvSpPr>
         <p:spPr>
           <a:xfrm>
-            <a:off x="685800" y="2103120"/>
-            <a:ext cx="7772400" cy="2377440"/>
-          </a:xfrm>
-          <a:prstGeom prst="rect">
-            <a:avLst/>
-          </a:prstGeom>
-        </p:spPr>
-        <p:txBody>
-          <a:bodyPr wrap="square" rtlCol="0">
-            <a:spAutoFit/>
-          </a:bodyPr>
-          <a:lstStyle/>
+            <a:off x="1371600" y="2377440"/>
+            <a:ext cx="7086600" cy="792480"/>
+          </a:xfrm>
+          <a:prstGeom prst="rect">
+            <a:avLst/>
+          </a:prstGeom>
+        </p:spPr>
+        <p:txBody>
+          <a:bodyPr wrap="square" rtlCol="0">
+            <a:spAutoFit/>
+          </a:bodyPr>
+          <a:lstStyle/>
+          <a:p>
+            <a:r>
+              <a:rPr b="1" sz="2400">
+                <a:solidFill>
+                  <a:srgbClr val="172033"/>
+                </a:solidFill>
+                <a:latin typeface="Aptos"/>
+              </a:rPr>
+              <a:t>Copilot in VS Code</a:t>
+            </a:r>
+          </a:p>
           <a:p>
             <a:r>
               <a:rPr b="1" sz="1600">
@@ -4995,29 +5006,18 @@
                 </a:solidFill>
                 <a:latin typeface="Aptos"/>
               </a:rPr>
-              <a:t>https://code.visualstudio.com/docs/copilot/overview</a:t>
-            </a:r>
-          </a:p>
-          <a:p>
-            <a:r>
-              <a:rPr b="1" sz="1600">
+              <a:t>code.visualstudio.com/docs/copilot/overview</a:t>
+            </a:r>
+          </a:p>
+          <a:p>
+            <a:r>
+              <a:rPr b="1" sz="600">
                 <a:solidFill>
                   <a:srgbClr val="1746D1"/>
                 </a:solidFill>
                 <a:latin typeface="Aptos"/>
               </a:rPr>
-              <a:t>https://code.visualstudio.com/docs/copilot/chat/chat-agent-mode</a:t>
-            </a:r>
-          </a:p>
-          <a:p>
-            <a:r>
-              <a:rPr b="1" sz="1600">
-                <a:solidFill>
-                  <a:srgbClr val="1746D1"/>
-                </a:solidFill>
-                <a:latin typeface="Aptos"/>
-              </a:rPr>
-              <a:t>https://code.visualstudio.com/docs/copilot/customization/custom-agents</a:t>
+              <a:t xml:space="preserve"> </a:t>
             </a:r>
           </a:p>
         </p:txBody>
@@ -5045,81 +5045,349 @@
           <a:lstStyle/>
           <a:p>
             <a:r>
+              <a:rPr b="1" sz="1900">
+                <a:solidFill>
+                  <a:srgbClr val="1746D1"/>
+                </a:solidFill>
+                <a:latin typeface="Aptos"/>
+              </a:rPr>
+              <a:t>MORE  ·  github.com/github/awesome-copilot</a:t>
+            </a:r>
+          </a:p>
+        </p:txBody>
+      </p:sp>
+      <p:sp>
+        <p:nvSpPr>
+          <p:cNvPr id="9" name="TextBox 9"/>
+          <p:cNvSpPr txBox="1"/>
+          <p:nvPr/>
+        </p:nvSpPr>
+        <p:spPr>
+          <a:xfrm>
+            <a:off x="685800" y="6300216"/>
+            <a:ext cx="6858000" cy="320040"/>
+          </a:xfrm>
+          <a:prstGeom prst="rect">
+            <a:avLst/>
+          </a:prstGeom>
+        </p:spPr>
+        <p:txBody>
+          <a:bodyPr wrap="square" rtlCol="0">
+            <a:spAutoFit/>
+          </a:bodyPr>
+          <a:lstStyle/>
+          <a:p>
+            <a:r>
+              <a:rPr b="1" sz="1200" spc="120">
+                <a:solidFill>
+                  <a:srgbClr val="7A8497"/>
+                </a:solidFill>
+                <a:latin typeface="Aptos"/>
+              </a:rPr>
+              <a:t>NDC OSLO × GITHUB COPILOT WORKSHOP</a:t>
+            </a:r>
+          </a:p>
+        </p:txBody>
+      </p:sp>
+      <p:sp>
+        <p:nvSpPr>
+          <p:cNvPr id="10" name="TextBox 10"/>
+          <p:cNvSpPr txBox="1"/>
+          <p:nvPr/>
+        </p:nvSpPr>
+        <p:spPr>
+          <a:xfrm>
+            <a:off x="8046720" y="6300216"/>
+            <a:ext cx="640080" cy="320040"/>
+          </a:xfrm>
+          <a:prstGeom prst="rect">
+            <a:avLst/>
+          </a:prstGeom>
+        </p:spPr>
+        <p:txBody>
+          <a:bodyPr wrap="square" rtlCol="0">
+            <a:spAutoFit/>
+          </a:bodyPr>
+          <a:lstStyle/>
+          <a:p>
+            <a:r>
+              <a:rPr b="1" sz="1300">
+                <a:solidFill>
+                  <a:srgbClr val="1746D1"/>
+                </a:solidFill>
+                <a:latin typeface="Aptos"/>
+              </a:rPr>
+              <a:t>06</a:t>
+            </a:r>
+          </a:p>
+        </p:txBody>
+      </p:sp>
+      <p:sp>
+        <p:nvSpPr>
+          <p:cNvPr id="11" name="TextBox 11"/>
+          <p:cNvSpPr txBox="1"/>
+          <p:nvPr/>
+        </p:nvSpPr>
+        <p:spPr>
+          <a:xfrm>
+            <a:off x="1371600" y="3200400"/>
+            <a:ext cx="7086600" cy="792480"/>
+          </a:xfrm>
+          <a:prstGeom prst="rect">
+            <a:avLst/>
+          </a:prstGeom>
+        </p:spPr>
+        <p:txBody>
+          <a:bodyPr wrap="square" rtlCol="0">
+            <a:spAutoFit/>
+          </a:bodyPr>
+          <a:lstStyle/>
+          <a:p>
+            <a:r>
+              <a:rPr b="1" sz="2400">
+                <a:solidFill>
+                  <a:srgbClr val="172033"/>
+                </a:solidFill>
+                <a:latin typeface="Aptos"/>
+              </a:rPr>
+              <a:t>Agent mode</a:t>
+            </a:r>
+          </a:p>
+          <a:p>
+            <a:r>
               <a:rPr b="1" sz="1600">
                 <a:solidFill>
                   <a:srgbClr val="1746D1"/>
                 </a:solidFill>
                 <a:latin typeface="Aptos"/>
               </a:rPr>
-              <a:t>MORE CUSTOMIZATIONS  ·  https://github.com/github/awesome-copilot</a:t>
-            </a:r>
-          </a:p>
-        </p:txBody>
-      </p:sp>
-      <p:sp>
-        <p:nvSpPr>
-          <p:cNvPr id="9" name="TextBox 9"/>
-          <p:cNvSpPr txBox="1"/>
-          <p:nvPr/>
-        </p:nvSpPr>
-        <p:spPr>
-          <a:xfrm>
-            <a:off x="685800" y="6355080"/>
-            <a:ext cx="6858000" cy="274320"/>
-          </a:xfrm>
-          <a:prstGeom prst="rect">
-            <a:avLst/>
-          </a:prstGeom>
-        </p:spPr>
-        <p:txBody>
-          <a:bodyPr wrap="square" rtlCol="0">
-            <a:spAutoFit/>
-          </a:bodyPr>
-          <a:lstStyle/>
-          <a:p>
-            <a:r>
-              <a:rPr b="1" sz="1000" spc="80">
-                <a:solidFill>
-                  <a:srgbClr val="7A8497"/>
-                </a:solidFill>
-                <a:latin typeface="Aptos"/>
-              </a:rPr>
-              <a:t>NDC OSLO × GITHUB COPILOT WORKSHOP</a:t>
-            </a:r>
-          </a:p>
-        </p:txBody>
-      </p:sp>
-      <p:sp>
-        <p:nvSpPr>
-          <p:cNvPr id="10" name="TextBox 10"/>
-          <p:cNvSpPr txBox="1"/>
-          <p:nvPr/>
-        </p:nvSpPr>
-        <p:spPr>
-          <a:xfrm>
-            <a:off x="8230000" y="6355080"/>
-            <a:ext cx="457200" cy="274320"/>
-          </a:xfrm>
-          <a:prstGeom prst="rect">
-            <a:avLst/>
-          </a:prstGeom>
-        </p:spPr>
-        <p:txBody>
-          <a:bodyPr wrap="square" rtlCol="0">
-            <a:spAutoFit/>
-          </a:bodyPr>
-          <a:lstStyle/>
-          <a:p>
-            <a:r>
-              <a:rPr b="1" sz="1000">
+              <a:t>code.visualstudio.com/docs/copilot/chat/chat-agent-mode</a:t>
+            </a:r>
+          </a:p>
+        </p:txBody>
+      </p:sp>
+      <p:sp>
+        <p:nvSpPr>
+          <p:cNvPr id="12" name="TextBox 12"/>
+          <p:cNvSpPr txBox="1"/>
+          <p:nvPr/>
+        </p:nvSpPr>
+        <p:spPr>
+          <a:xfrm>
+            <a:off x="1371600" y="4023360"/>
+            <a:ext cx="7086600" cy="792480"/>
+          </a:xfrm>
+          <a:prstGeom prst="rect">
+            <a:avLst/>
+          </a:prstGeom>
+        </p:spPr>
+        <p:txBody>
+          <a:bodyPr wrap="square" rtlCol="0">
+            <a:spAutoFit/>
+          </a:bodyPr>
+          <a:lstStyle/>
+          <a:p>
+            <a:r>
+              <a:rPr b="1" sz="2400">
+                <a:solidFill>
+                  <a:srgbClr val="172033"/>
+                </a:solidFill>
+                <a:latin typeface="Aptos"/>
+              </a:rPr>
+              <a:t>Custom agents</a:t>
+            </a:r>
+          </a:p>
+          <a:p>
+            <a:r>
+              <a:rPr b="1" sz="1600">
                 <a:solidFill>
                   <a:srgbClr val="1746D1"/>
                 </a:solidFill>
                 <a:latin typeface="Aptos"/>
               </a:rPr>
-              <a:t>06</a:t>
-            </a:r>
-          </a:p>
+              <a:t>code.visualstudio.com/docs/copilot/customization/custom-agents</a:t>
+            </a:r>
+          </a:p>
+        </p:txBody>
+      </p:sp>
+      <p:sp>
+        <p:nvSpPr>
+          <p:cNvPr id="13" name="TextBox 13"/>
+          <p:cNvSpPr txBox="1"/>
+          <p:nvPr/>
+        </p:nvSpPr>
+        <p:spPr>
+          <a:xfrm>
+            <a:off x="685800" y="2465832"/>
+            <a:ext cx="594360" cy="320040"/>
+          </a:xfrm>
+          <a:prstGeom prst="rect">
+            <a:avLst/>
+          </a:prstGeom>
+        </p:spPr>
+        <p:txBody>
+          <a:bodyPr wrap="square" rtlCol="0">
+            <a:spAutoFit/>
+          </a:bodyPr>
+          <a:lstStyle/>
+          <a:p>
+            <a:r>
+              <a:rPr b="1" sz="1700" spc="60">
+                <a:solidFill>
+                  <a:srgbClr val="1746D1"/>
+                </a:solidFill>
+                <a:latin typeface="Aptos"/>
+              </a:rPr>
+              <a:t>01</a:t>
+            </a:r>
+          </a:p>
+        </p:txBody>
+      </p:sp>
+      <p:sp>
+        <p:nvSpPr>
+          <p:cNvPr id="14" name="TextBox 14"/>
+          <p:cNvSpPr txBox="1"/>
+          <p:nvPr/>
+        </p:nvSpPr>
+        <p:spPr>
+          <a:xfrm>
+            <a:off x="685800" y="3288792"/>
+            <a:ext cx="594360" cy="320040"/>
+          </a:xfrm>
+          <a:prstGeom prst="rect">
+            <a:avLst/>
+          </a:prstGeom>
+        </p:spPr>
+        <p:txBody>
+          <a:bodyPr wrap="square" rtlCol="0">
+            <a:spAutoFit/>
+          </a:bodyPr>
+          <a:lstStyle/>
+          <a:p>
+            <a:r>
+              <a:rPr b="1" sz="1700" spc="60">
+                <a:solidFill>
+                  <a:srgbClr val="1746D1"/>
+                </a:solidFill>
+                <a:latin typeface="Aptos"/>
+              </a:rPr>
+              <a:t>02</a:t>
+            </a:r>
+          </a:p>
+        </p:txBody>
+      </p:sp>
+      <p:sp>
+        <p:nvSpPr>
+          <p:cNvPr id="15" name="TextBox 15"/>
+          <p:cNvSpPr txBox="1"/>
+          <p:nvPr/>
+        </p:nvSpPr>
+        <p:spPr>
+          <a:xfrm>
+            <a:off x="685800" y="4111752"/>
+            <a:ext cx="594360" cy="320040"/>
+          </a:xfrm>
+          <a:prstGeom prst="rect">
+            <a:avLst/>
+          </a:prstGeom>
+        </p:spPr>
+        <p:txBody>
+          <a:bodyPr wrap="square" rtlCol="0">
+            <a:spAutoFit/>
+          </a:bodyPr>
+          <a:lstStyle/>
+          <a:p>
+            <a:r>
+              <a:rPr b="1" sz="1700" spc="60">
+                <a:solidFill>
+                  <a:srgbClr val="1746D1"/>
+                </a:solidFill>
+                <a:latin typeface="Aptos"/>
+              </a:rPr>
+              <a:t>03</a:t>
+            </a:r>
+          </a:p>
+        </p:txBody>
+      </p:sp>
+      <p:sp>
+        <p:nvSpPr>
+          <p:cNvPr id="16" name="Shape 16"/>
+          <p:cNvSpPr/>
+          <p:nvPr/>
+        </p:nvSpPr>
+        <p:spPr>
+          <a:xfrm>
+            <a:off x="685800" y="3063240"/>
+            <a:ext cx="7772400" cy="12700"/>
+          </a:xfrm>
+          <a:prstGeom prst="rect">
+            <a:avLst/>
+          </a:prstGeom>
+          <a:solidFill>
+            <a:srgbClr val="CFD8E8"/>
+          </a:solidFill>
+          <a:ln>
+            <a:noFill/>
+          </a:ln>
+        </p:spPr>
+        <p:txBody>
+          <a:bodyPr rtlCol="0" anchor="ctr"/>
+          <a:lstStyle/>
+          <a:p/>
+        </p:txBody>
+      </p:sp>
+      <p:sp>
+        <p:nvSpPr>
+          <p:cNvPr id="17" name="Shape 17"/>
+          <p:cNvSpPr/>
+          <p:nvPr/>
+        </p:nvSpPr>
+        <p:spPr>
+          <a:xfrm>
+            <a:off x="685800" y="3886200"/>
+            <a:ext cx="7772400" cy="12700"/>
+          </a:xfrm>
+          <a:prstGeom prst="rect">
+            <a:avLst/>
+          </a:prstGeom>
+          <a:solidFill>
+            <a:srgbClr val="CFD8E8"/>
+          </a:solidFill>
+          <a:ln>
+            <a:noFill/>
+          </a:ln>
+        </p:spPr>
+        <p:txBody>
+          <a:bodyPr rtlCol="0" anchor="ctr"/>
+          <a:lstStyle/>
+          <a:p/>
+        </p:txBody>
+      </p:sp>
+      <p:sp>
+        <p:nvSpPr>
+          <p:cNvPr id="18" name="Shape 18"/>
+          <p:cNvSpPr/>
+          <p:nvPr/>
+        </p:nvSpPr>
+        <p:spPr>
+          <a:xfrm>
+            <a:off x="685800" y="2011680"/>
+            <a:ext cx="594360" cy="54864"/>
+          </a:xfrm>
+          <a:prstGeom prst="rect">
+            <a:avLst/>
+          </a:prstGeom>
+          <a:solidFill>
+            <a:srgbClr val="E45A3E"/>
+          </a:solidFill>
+          <a:ln>
+            <a:noFill/>
+          </a:ln>
+        </p:spPr>
+        <p:txBody>
+          <a:bodyPr rtlCol="0" anchor="ctr"/>
+          <a:lstStyle/>
+          <a:p/>
         </p:txBody>
       </p:sp>
     </p:spTree>
@@ -5531,23 +5799,23 @@
         </p:nvSpPr>
         <p:spPr>
           <a:xfrm>
-            <a:off x="960120" y="365760"/>
-            <a:ext cx="5486400" cy="274320"/>
-          </a:xfrm>
-          <a:prstGeom prst="rect">
-            <a:avLst/>
-          </a:prstGeom>
-        </p:spPr>
-        <p:txBody>
-          <a:bodyPr wrap="square" rtlCol="0">
-            <a:spAutoFit/>
-          </a:bodyPr>
-          <a:lstStyle/>
-          <a:p>
-            <a:r>
-              <a:rPr b="1" sz="1200" spc="120">
-                <a:solidFill>
-                  <a:srgbClr val="1746D1"/>
+            <a:off x="960120" y="347472"/>
+            <a:ext cx="6858000" cy="310896"/>
+          </a:xfrm>
+          <a:prstGeom prst="rect">
+            <a:avLst/>
+          </a:prstGeom>
+        </p:spPr>
+        <p:txBody>
+          <a:bodyPr wrap="square" rtlCol="0">
+            <a:spAutoFit/>
+          </a:bodyPr>
+          <a:lstStyle/>
+          <a:p>
+            <a:r>
+              <a:rPr b="1" sz="1500" spc="240">
+                <a:solidFill>
+                  <a:srgbClr val="C53F25"/>
                 </a:solidFill>
                 <a:latin typeface="Aptos"/>
               </a:rPr>
@@ -5564,27 +5832,27 @@
         </p:nvSpPr>
         <p:spPr>
           <a:xfrm>
-            <a:off x="685800" y="868680"/>
-            <a:ext cx="7772400" cy="1005840"/>
-          </a:xfrm>
-          <a:prstGeom prst="rect">
-            <a:avLst/>
-          </a:prstGeom>
-        </p:spPr>
-        <p:txBody>
-          <a:bodyPr wrap="square" rtlCol="0">
-            <a:spAutoFit/>
-          </a:bodyPr>
-          <a:lstStyle/>
-          <a:p>
-            <a:r>
-              <a:rPr b="1" sz="3400" spc="-80">
+            <a:off x="685800" y="754380"/>
+            <a:ext cx="7772400" cy="1188720"/>
+          </a:xfrm>
+          <a:prstGeom prst="rect">
+            <a:avLst/>
+          </a:prstGeom>
+        </p:spPr>
+        <p:txBody>
+          <a:bodyPr wrap="square" rtlCol="0">
+            <a:spAutoFit/>
+          </a:bodyPr>
+          <a:lstStyle/>
+          <a:p>
+            <a:r>
+              <a:rPr b="1" sz="4200" spc="-60">
                 <a:solidFill>
                   <a:srgbClr val="172033"/>
                 </a:solidFill>
                 <a:latin typeface="Aptos Display"/>
               </a:rPr>
-              <a:t>Copilot App lab: what we'll do</a:t>
+              <a:t>What we’ll do in the app</a:t>
             </a:r>
           </a:p>
         </p:txBody>
@@ -5597,49 +5865,49 @@
         </p:nvSpPr>
         <p:spPr>
           <a:xfrm>
-            <a:off x="685800" y="2103120"/>
-            <a:ext cx="7772400" cy="2377440"/>
-          </a:xfrm>
-          <a:prstGeom prst="rect">
-            <a:avLst/>
-          </a:prstGeom>
-        </p:spPr>
-        <p:txBody>
-          <a:bodyPr wrap="square" rtlCol="0">
-            <a:spAutoFit/>
-          </a:bodyPr>
-          <a:lstStyle/>
-          <a:p>
-            <a:r>
-              <a:rPr sz="2000">
+            <a:off x="1371600" y="2377440"/>
+            <a:ext cx="7086600" cy="792480"/>
+          </a:xfrm>
+          <a:prstGeom prst="rect">
+            <a:avLst/>
+          </a:prstGeom>
+        </p:spPr>
+        <p:txBody>
+          <a:bodyPr wrap="square" rtlCol="0">
+            <a:spAutoFit/>
+          </a:bodyPr>
+          <a:lstStyle/>
+          <a:p>
+            <a:r>
+              <a:rPr b="1" sz="2400">
+                <a:solidFill>
+                  <a:srgbClr val="172033"/>
+                </a:solidFill>
+                <a:latin typeface="Aptos"/>
+              </a:rPr>
+              <a:t>Install and orient</a:t>
+            </a:r>
+          </a:p>
+          <a:p>
+            <a:r>
+              <a:rPr sz="1700">
                 <a:solidFill>
                   <a:srgbClr val="455166"/>
                 </a:solidFill>
                 <a:latin typeface="Aptos"/>
               </a:rPr>
-              <a:t>Install and orient  ·  complete the guided app tour.</a:t>
-            </a:r>
-          </a:p>
-          <a:p>
-            <a:r>
-              <a:rPr sz="2000">
+              <a:t>Set up the app and walk the guided product tour.</a:t>
+            </a:r>
+          </a:p>
+          <a:p>
+            <a:r>
+              <a:rPr sz="600">
                 <a:solidFill>
                   <a:srgbClr val="455166"/>
                 </a:solidFill>
                 <a:latin typeface="Aptos"/>
               </a:rPr>
-              <a:t>Run Tailspin sessions  ·  add custom instructions  ·  use Plan and Autopilot.</a:t>
-            </a:r>
-          </a:p>
-          <a:p>
-            <a:r>
-              <a:rPr sz="2000">
-                <a:solidFill>
-                  <a:srgbClr val="455166"/>
-                </a:solidFill>
-                <a:latin typeface="Aptos"/>
-              </a:rPr>
-              <a:t>Test with Playwright MCP  ·  land with Agent Merge  ·  plan on canvases.</a:t>
+              <a:t xml:space="preserve"> </a:t>
             </a:r>
           </a:p>
         </p:txBody>
@@ -5659,7 +5927,7 @@
             <a:avLst/>
           </a:prstGeom>
           <a:solidFill>
-            <a:srgbClr val="E8F0FF"/>
+            <a:srgbClr val="FFF3EF"/>
           </a:solidFill>
         </p:spPr>
         <p:txBody>
@@ -5667,13 +5935,13 @@
           <a:lstStyle/>
           <a:p>
             <a:r>
-              <a:rPr b="1" sz="1600">
-                <a:solidFill>
-                  <a:srgbClr val="1746D1"/>
-                </a:solidFill>
-                <a:latin typeface="Aptos"/>
-              </a:rPr>
-              <a:t>DELIVER  ·  Move from issue to reviewed, tested, and merged change.</a:t>
+              <a:rPr b="1" sz="1900">
+                <a:solidFill>
+                  <a:srgbClr val="C53F25"/>
+                </a:solidFill>
+                <a:latin typeface="Aptos"/>
+              </a:rPr>
+              <a:t>DELIVER  ·  From issue to reviewed, tested, merged change.</a:t>
             </a:r>
           </a:p>
         </p:txBody>
@@ -5686,21 +5954,21 @@
         </p:nvSpPr>
         <p:spPr>
           <a:xfrm>
-            <a:off x="685800" y="6355080"/>
-            <a:ext cx="6858000" cy="274320"/>
-          </a:xfrm>
-          <a:prstGeom prst="rect">
-            <a:avLst/>
-          </a:prstGeom>
-        </p:spPr>
-        <p:txBody>
-          <a:bodyPr wrap="square" rtlCol="0">
-            <a:spAutoFit/>
-          </a:bodyPr>
-          <a:lstStyle/>
-          <a:p>
-            <a:r>
-              <a:rPr b="1" sz="1000" spc="80">
+            <a:off x="685800" y="6300216"/>
+            <a:ext cx="6858000" cy="320040"/>
+          </a:xfrm>
+          <a:prstGeom prst="rect">
+            <a:avLst/>
+          </a:prstGeom>
+        </p:spPr>
+        <p:txBody>
+          <a:bodyPr wrap="square" rtlCol="0">
+            <a:spAutoFit/>
+          </a:bodyPr>
+          <a:lstStyle/>
+          <a:p>
+            <a:r>
+              <a:rPr b="1" sz="1200" spc="120">
                 <a:solidFill>
                   <a:srgbClr val="7A8497"/>
                 </a:solidFill>
@@ -5719,29 +5987,297 @@
         </p:nvSpPr>
         <p:spPr>
           <a:xfrm>
-            <a:off x="8230000" y="6355080"/>
-            <a:ext cx="457200" cy="274320"/>
-          </a:xfrm>
-          <a:prstGeom prst="rect">
-            <a:avLst/>
-          </a:prstGeom>
-        </p:spPr>
-        <p:txBody>
-          <a:bodyPr wrap="square" rtlCol="0">
-            <a:spAutoFit/>
-          </a:bodyPr>
-          <a:lstStyle/>
-          <a:p>
-            <a:r>
-              <a:rPr b="1" sz="1000">
-                <a:solidFill>
-                  <a:srgbClr val="1746D1"/>
+            <a:off x="8046720" y="6300216"/>
+            <a:ext cx="640080" cy="320040"/>
+          </a:xfrm>
+          <a:prstGeom prst="rect">
+            <a:avLst/>
+          </a:prstGeom>
+        </p:spPr>
+        <p:txBody>
+          <a:bodyPr wrap="square" rtlCol="0">
+            <a:spAutoFit/>
+          </a:bodyPr>
+          <a:lstStyle/>
+          <a:p>
+            <a:r>
+              <a:rPr b="1" sz="1300">
+                <a:solidFill>
+                  <a:srgbClr val="C53F25"/>
                 </a:solidFill>
                 <a:latin typeface="Aptos"/>
               </a:rPr>
               <a:t>07</a:t>
             </a:r>
           </a:p>
+        </p:txBody>
+      </p:sp>
+      <p:sp>
+        <p:nvSpPr>
+          <p:cNvPr id="11" name="TextBox 11"/>
+          <p:cNvSpPr txBox="1"/>
+          <p:nvPr/>
+        </p:nvSpPr>
+        <p:spPr>
+          <a:xfrm>
+            <a:off x="1371600" y="3200400"/>
+            <a:ext cx="7086600" cy="792480"/>
+          </a:xfrm>
+          <a:prstGeom prst="rect">
+            <a:avLst/>
+          </a:prstGeom>
+        </p:spPr>
+        <p:txBody>
+          <a:bodyPr wrap="square" rtlCol="0">
+            <a:spAutoFit/>
+          </a:bodyPr>
+          <a:lstStyle/>
+          <a:p>
+            <a:r>
+              <a:rPr b="1" sz="2400">
+                <a:solidFill>
+                  <a:srgbClr val="172033"/>
+                </a:solidFill>
+                <a:latin typeface="Aptos"/>
+              </a:rPr>
+              <a:t>Run real agent sessions</a:t>
+            </a:r>
+          </a:p>
+          <a:p>
+            <a:r>
+              <a:rPr sz="1700">
+                <a:solidFill>
+                  <a:srgbClr val="455166"/>
+                </a:solidFill>
+                <a:latin typeface="Aptos"/>
+              </a:rPr>
+              <a:t>Custom instructions, Plan mode, and Autopilot on Tailspin.</a:t>
+            </a:r>
+          </a:p>
+        </p:txBody>
+      </p:sp>
+      <p:sp>
+        <p:nvSpPr>
+          <p:cNvPr id="12" name="TextBox 12"/>
+          <p:cNvSpPr txBox="1"/>
+          <p:nvPr/>
+        </p:nvSpPr>
+        <p:spPr>
+          <a:xfrm>
+            <a:off x="1371600" y="4023360"/>
+            <a:ext cx="7086600" cy="792480"/>
+          </a:xfrm>
+          <a:prstGeom prst="rect">
+            <a:avLst/>
+          </a:prstGeom>
+        </p:spPr>
+        <p:txBody>
+          <a:bodyPr wrap="square" rtlCol="0">
+            <a:spAutoFit/>
+          </a:bodyPr>
+          <a:lstStyle/>
+          <a:p>
+            <a:r>
+              <a:rPr b="1" sz="2400">
+                <a:solidFill>
+                  <a:srgbClr val="172033"/>
+                </a:solidFill>
+                <a:latin typeface="Aptos"/>
+              </a:rPr>
+              <a:t>Test, review, and merge</a:t>
+            </a:r>
+          </a:p>
+          <a:p>
+            <a:r>
+              <a:rPr sz="1700">
+                <a:solidFill>
+                  <a:srgbClr val="455166"/>
+                </a:solidFill>
+                <a:latin typeface="Aptos"/>
+              </a:rPr>
+              <a:t>Playwright MCP, Agent Merge, and planning on canvases.</a:t>
+            </a:r>
+          </a:p>
+        </p:txBody>
+      </p:sp>
+      <p:sp>
+        <p:nvSpPr>
+          <p:cNvPr id="13" name="TextBox 13"/>
+          <p:cNvSpPr txBox="1"/>
+          <p:nvPr/>
+        </p:nvSpPr>
+        <p:spPr>
+          <a:xfrm>
+            <a:off x="685800" y="2465832"/>
+            <a:ext cx="594360" cy="320040"/>
+          </a:xfrm>
+          <a:prstGeom prst="rect">
+            <a:avLst/>
+          </a:prstGeom>
+        </p:spPr>
+        <p:txBody>
+          <a:bodyPr wrap="square" rtlCol="0">
+            <a:spAutoFit/>
+          </a:bodyPr>
+          <a:lstStyle/>
+          <a:p>
+            <a:r>
+              <a:rPr b="1" sz="1700" spc="60">
+                <a:solidFill>
+                  <a:srgbClr val="C53F25"/>
+                </a:solidFill>
+                <a:latin typeface="Aptos"/>
+              </a:rPr>
+              <a:t>01</a:t>
+            </a:r>
+          </a:p>
+        </p:txBody>
+      </p:sp>
+      <p:sp>
+        <p:nvSpPr>
+          <p:cNvPr id="14" name="TextBox 14"/>
+          <p:cNvSpPr txBox="1"/>
+          <p:nvPr/>
+        </p:nvSpPr>
+        <p:spPr>
+          <a:xfrm>
+            <a:off x="685800" y="3288792"/>
+            <a:ext cx="594360" cy="320040"/>
+          </a:xfrm>
+          <a:prstGeom prst="rect">
+            <a:avLst/>
+          </a:prstGeom>
+        </p:spPr>
+        <p:txBody>
+          <a:bodyPr wrap="square" rtlCol="0">
+            <a:spAutoFit/>
+          </a:bodyPr>
+          <a:lstStyle/>
+          <a:p>
+            <a:r>
+              <a:rPr b="1" sz="1700" spc="60">
+                <a:solidFill>
+                  <a:srgbClr val="C53F25"/>
+                </a:solidFill>
+                <a:latin typeface="Aptos"/>
+              </a:rPr>
+              <a:t>02</a:t>
+            </a:r>
+          </a:p>
+        </p:txBody>
+      </p:sp>
+      <p:sp>
+        <p:nvSpPr>
+          <p:cNvPr id="15" name="TextBox 15"/>
+          <p:cNvSpPr txBox="1"/>
+          <p:nvPr/>
+        </p:nvSpPr>
+        <p:spPr>
+          <a:xfrm>
+            <a:off x="685800" y="4111752"/>
+            <a:ext cx="594360" cy="320040"/>
+          </a:xfrm>
+          <a:prstGeom prst="rect">
+            <a:avLst/>
+          </a:prstGeom>
+        </p:spPr>
+        <p:txBody>
+          <a:bodyPr wrap="square" rtlCol="0">
+            <a:spAutoFit/>
+          </a:bodyPr>
+          <a:lstStyle/>
+          <a:p>
+            <a:r>
+              <a:rPr b="1" sz="1700" spc="60">
+                <a:solidFill>
+                  <a:srgbClr val="C53F25"/>
+                </a:solidFill>
+                <a:latin typeface="Aptos"/>
+              </a:rPr>
+              <a:t>03</a:t>
+            </a:r>
+          </a:p>
+        </p:txBody>
+      </p:sp>
+      <p:sp>
+        <p:nvSpPr>
+          <p:cNvPr id="16" name="Shape 16"/>
+          <p:cNvSpPr/>
+          <p:nvPr/>
+        </p:nvSpPr>
+        <p:spPr>
+          <a:xfrm>
+            <a:off x="685800" y="3063240"/>
+            <a:ext cx="7772400" cy="12700"/>
+          </a:xfrm>
+          <a:prstGeom prst="rect">
+            <a:avLst/>
+          </a:prstGeom>
+          <a:solidFill>
+            <a:srgbClr val="F0D7CF"/>
+          </a:solidFill>
+          <a:ln>
+            <a:noFill/>
+          </a:ln>
+        </p:spPr>
+        <p:txBody>
+          <a:bodyPr rtlCol="0" anchor="ctr"/>
+          <a:lstStyle/>
+          <a:p/>
+        </p:txBody>
+      </p:sp>
+      <p:sp>
+        <p:nvSpPr>
+          <p:cNvPr id="17" name="Shape 17"/>
+          <p:cNvSpPr/>
+          <p:nvPr/>
+        </p:nvSpPr>
+        <p:spPr>
+          <a:xfrm>
+            <a:off x="685800" y="3886200"/>
+            <a:ext cx="7772400" cy="12700"/>
+          </a:xfrm>
+          <a:prstGeom prst="rect">
+            <a:avLst/>
+          </a:prstGeom>
+          <a:solidFill>
+            <a:srgbClr val="F0D7CF"/>
+          </a:solidFill>
+          <a:ln>
+            <a:noFill/>
+          </a:ln>
+        </p:spPr>
+        <p:txBody>
+          <a:bodyPr rtlCol="0" anchor="ctr"/>
+          <a:lstStyle/>
+          <a:p/>
+        </p:txBody>
+      </p:sp>
+      <p:sp>
+        <p:nvSpPr>
+          <p:cNvPr id="18" name="Shape 18"/>
+          <p:cNvSpPr/>
+          <p:nvPr/>
+        </p:nvSpPr>
+        <p:spPr>
+          <a:xfrm>
+            <a:off x="685800" y="2011680"/>
+            <a:ext cx="594360" cy="54864"/>
+          </a:xfrm>
+          <a:prstGeom prst="rect">
+            <a:avLst/>
+          </a:prstGeom>
+          <a:solidFill>
+            <a:srgbClr val="E45A3E"/>
+          </a:solidFill>
+          <a:ln>
+            <a:noFill/>
+          </a:ln>
+        </p:spPr>
+        <p:txBody>
+          <a:bodyPr rtlCol="0" anchor="ctr"/>
+          <a:lstStyle/>
+          <a:p/>
         </p:txBody>
       </p:sp>
     </p:spTree>
@@ -7086,21 +7622,21 @@
         </p:nvSpPr>
         <p:spPr>
           <a:xfrm>
-            <a:off x="960120" y="365760"/>
-            <a:ext cx="5486400" cy="274320"/>
-          </a:xfrm>
-          <a:prstGeom prst="rect">
-            <a:avLst/>
-          </a:prstGeom>
-        </p:spPr>
-        <p:txBody>
-          <a:bodyPr wrap="square" rtlCol="0">
-            <a:spAutoFit/>
-          </a:bodyPr>
-          <a:lstStyle/>
-          <a:p>
-            <a:r>
-              <a:rPr b="1" sz="1200" spc="120">
+            <a:off x="960120" y="347472"/>
+            <a:ext cx="6858000" cy="310896"/>
+          </a:xfrm>
+          <a:prstGeom prst="rect">
+            <a:avLst/>
+          </a:prstGeom>
+        </p:spPr>
+        <p:txBody>
+          <a:bodyPr wrap="square" rtlCol="0">
+            <a:spAutoFit/>
+          </a:bodyPr>
+          <a:lstStyle/>
+          <a:p>
+            <a:r>
+              <a:rPr b="1" sz="1500" spc="240">
                 <a:solidFill>
                   <a:srgbClr val="1746D1"/>
                 </a:solidFill>
@@ -7119,21 +7655,21 @@
         </p:nvSpPr>
         <p:spPr>
           <a:xfrm>
-            <a:off x="685800" y="868680"/>
-            <a:ext cx="7772400" cy="1005840"/>
-          </a:xfrm>
-          <a:prstGeom prst="rect">
-            <a:avLst/>
-          </a:prstGeom>
-        </p:spPr>
-        <p:txBody>
-          <a:bodyPr wrap="square" rtlCol="0">
-            <a:spAutoFit/>
-          </a:bodyPr>
-          <a:lstStyle/>
-          <a:p>
-            <a:r>
-              <a:rPr b="1" sz="3400" spc="-80">
+            <a:off x="685800" y="754380"/>
+            <a:ext cx="7772400" cy="1188720"/>
+          </a:xfrm>
+          <a:prstGeom prst="rect">
+            <a:avLst/>
+          </a:prstGeom>
+        </p:spPr>
+        <p:txBody>
+          <a:bodyPr wrap="square" rtlCol="0">
+            <a:spAutoFit/>
+          </a:bodyPr>
+          <a:lstStyle/>
+          <a:p>
+            <a:r>
+              <a:rPr b="1" sz="4200" spc="-60">
                 <a:solidFill>
                   <a:srgbClr val="172033"/>
                 </a:solidFill>
@@ -7152,49 +7688,49 @@
         </p:nvSpPr>
         <p:spPr>
           <a:xfrm>
-            <a:off x="685800" y="2103120"/>
-            <a:ext cx="7772400" cy="2377440"/>
-          </a:xfrm>
-          <a:prstGeom prst="rect">
-            <a:avLst/>
-          </a:prstGeom>
-        </p:spPr>
-        <p:txBody>
-          <a:bodyPr wrap="square" rtlCol="0">
-            <a:spAutoFit/>
-          </a:bodyPr>
-          <a:lstStyle/>
-          <a:p>
-            <a:r>
-              <a:rPr sz="2000">
+            <a:off x="1371600" y="2377440"/>
+            <a:ext cx="7086600" cy="792480"/>
+          </a:xfrm>
+          <a:prstGeom prst="rect">
+            <a:avLst/>
+          </a:prstGeom>
+        </p:spPr>
+        <p:txBody>
+          <a:bodyPr wrap="square" rtlCol="0">
+            <a:spAutoFit/>
+          </a:bodyPr>
+          <a:lstStyle/>
+          <a:p>
+            <a:r>
+              <a:rPr b="1" sz="2400">
+                <a:solidFill>
+                  <a:srgbClr val="172033"/>
+                </a:solidFill>
+                <a:latin typeface="Aptos"/>
+              </a:rPr>
+              <a:t>VS Code — agents in your editor</a:t>
+            </a:r>
+          </a:p>
+          <a:p>
+            <a:r>
+              <a:rPr sz="1700">
                 <a:solidFill>
                   <a:srgbClr val="455166"/>
                 </a:solidFill>
                 <a:latin typeface="Aptos"/>
               </a:rPr>
-              <a:t>01  VS Code — build with local agents, skills, hooks, and browser tools.</a:t>
-            </a:r>
-          </a:p>
-          <a:p>
-            <a:r>
-              <a:rPr sz="2000">
+              <a:t>Skills, hooks, browser tools, and Plan mode.</a:t>
+            </a:r>
+          </a:p>
+          <a:p>
+            <a:r>
+              <a:rPr sz="600">
                 <a:solidFill>
                   <a:srgbClr val="455166"/>
                 </a:solidFill>
                 <a:latin typeface="Aptos"/>
               </a:rPr>
-              <a:t>02  Copilot App — move from issue to implementation, review, testing, and merge.</a:t>
-            </a:r>
-          </a:p>
-          <a:p>
-            <a:r>
-              <a:rPr sz="2000">
-                <a:solidFill>
-                  <a:srgbClr val="455166"/>
-                </a:solidFill>
-                <a:latin typeface="Aptos"/>
-              </a:rPr>
-              <a:t>Keep the workshop site open as your shared route map.</a:t>
+              <a:t xml:space="preserve"> </a:t>
             </a:r>
           </a:p>
         </p:txBody>
@@ -7222,13 +7758,13 @@
           <a:lstStyle/>
           <a:p>
             <a:r>
-              <a:rPr b="1" sz="1600">
+              <a:rPr b="1" sz="1900">
                 <a:solidFill>
                   <a:srgbClr val="1746D1"/>
                 </a:solidFill>
                 <a:latin typeface="Aptos"/>
               </a:rPr>
-              <a:t>OUTCOME  ·  Complete two practical, repo-backed development loops.</a:t>
+              <a:t>OUTCOME  ·  Two practical, repo-backed development loops.</a:t>
             </a:r>
           </a:p>
         </p:txBody>
@@ -7241,21 +7777,21 @@
         </p:nvSpPr>
         <p:spPr>
           <a:xfrm>
-            <a:off x="685800" y="6355080"/>
-            <a:ext cx="6858000" cy="274320"/>
-          </a:xfrm>
-          <a:prstGeom prst="rect">
-            <a:avLst/>
-          </a:prstGeom>
-        </p:spPr>
-        <p:txBody>
-          <a:bodyPr wrap="square" rtlCol="0">
-            <a:spAutoFit/>
-          </a:bodyPr>
-          <a:lstStyle/>
-          <a:p>
-            <a:r>
-              <a:rPr b="1" sz="1000" spc="80">
+            <a:off x="685800" y="6300216"/>
+            <a:ext cx="6858000" cy="320040"/>
+          </a:xfrm>
+          <a:prstGeom prst="rect">
+            <a:avLst/>
+          </a:prstGeom>
+        </p:spPr>
+        <p:txBody>
+          <a:bodyPr wrap="square" rtlCol="0">
+            <a:spAutoFit/>
+          </a:bodyPr>
+          <a:lstStyle/>
+          <a:p>
+            <a:r>
+              <a:rPr b="1" sz="1200" spc="120">
                 <a:solidFill>
                   <a:srgbClr val="7A8497"/>
                 </a:solidFill>
@@ -7274,21 +7810,21 @@
         </p:nvSpPr>
         <p:spPr>
           <a:xfrm>
-            <a:off x="8230000" y="6355080"/>
-            <a:ext cx="457200" cy="274320"/>
-          </a:xfrm>
-          <a:prstGeom prst="rect">
-            <a:avLst/>
-          </a:prstGeom>
-        </p:spPr>
-        <p:txBody>
-          <a:bodyPr wrap="square" rtlCol="0">
-            <a:spAutoFit/>
-          </a:bodyPr>
-          <a:lstStyle/>
-          <a:p>
-            <a:r>
-              <a:rPr b="1" sz="1000">
+            <a:off x="8046720" y="6300216"/>
+            <a:ext cx="640080" cy="320040"/>
+          </a:xfrm>
+          <a:prstGeom prst="rect">
+            <a:avLst/>
+          </a:prstGeom>
+        </p:spPr>
+        <p:txBody>
+          <a:bodyPr wrap="square" rtlCol="0">
+            <a:spAutoFit/>
+          </a:bodyPr>
+          <a:lstStyle/>
+          <a:p>
+            <a:r>
+              <a:rPr b="1" sz="1300">
                 <a:solidFill>
                   <a:srgbClr val="1746D1"/>
                 </a:solidFill>
@@ -7297,6 +7833,274 @@
               <a:t>02</a:t>
             </a:r>
           </a:p>
+        </p:txBody>
+      </p:sp>
+      <p:sp>
+        <p:nvSpPr>
+          <p:cNvPr id="11" name="TextBox 11"/>
+          <p:cNvSpPr txBox="1"/>
+          <p:nvPr/>
+        </p:nvSpPr>
+        <p:spPr>
+          <a:xfrm>
+            <a:off x="1371600" y="3200400"/>
+            <a:ext cx="7086600" cy="792480"/>
+          </a:xfrm>
+          <a:prstGeom prst="rect">
+            <a:avLst/>
+          </a:prstGeom>
+        </p:spPr>
+        <p:txBody>
+          <a:bodyPr wrap="square" rtlCol="0">
+            <a:spAutoFit/>
+          </a:bodyPr>
+          <a:lstStyle/>
+          <a:p>
+            <a:r>
+              <a:rPr b="1" sz="2400">
+                <a:solidFill>
+                  <a:srgbClr val="172033"/>
+                </a:solidFill>
+                <a:latin typeface="Aptos"/>
+              </a:rPr>
+              <a:t>Copilot app — issue to merge</a:t>
+            </a:r>
+          </a:p>
+          <a:p>
+            <a:r>
+              <a:rPr sz="1700">
+                <a:solidFill>
+                  <a:srgbClr val="455166"/>
+                </a:solidFill>
+                <a:latin typeface="Aptos"/>
+              </a:rPr>
+              <a:t>Sessions, Plan, Autopilot, MCP testing, and Agent Merge.</a:t>
+            </a:r>
+          </a:p>
+        </p:txBody>
+      </p:sp>
+      <p:sp>
+        <p:nvSpPr>
+          <p:cNvPr id="12" name="TextBox 12"/>
+          <p:cNvSpPr txBox="1"/>
+          <p:nvPr/>
+        </p:nvSpPr>
+        <p:spPr>
+          <a:xfrm>
+            <a:off x="1371600" y="4023360"/>
+            <a:ext cx="7086600" cy="792480"/>
+          </a:xfrm>
+          <a:prstGeom prst="rect">
+            <a:avLst/>
+          </a:prstGeom>
+        </p:spPr>
+        <p:txBody>
+          <a:bodyPr wrap="square" rtlCol="0">
+            <a:spAutoFit/>
+          </a:bodyPr>
+          <a:lstStyle/>
+          <a:p>
+            <a:r>
+              <a:rPr b="1" sz="2400">
+                <a:solidFill>
+                  <a:srgbClr val="172033"/>
+                </a:solidFill>
+                <a:latin typeface="Aptos"/>
+              </a:rPr>
+              <a:t>One shared route map</a:t>
+            </a:r>
+          </a:p>
+          <a:p>
+            <a:r>
+              <a:rPr sz="1700">
+                <a:solidFill>
+                  <a:srgbClr val="455166"/>
+                </a:solidFill>
+                <a:latin typeface="Aptos"/>
+              </a:rPr>
+              <a:t>Keep the site open; progress saves in your browser.</a:t>
+            </a:r>
+          </a:p>
+        </p:txBody>
+      </p:sp>
+      <p:sp>
+        <p:nvSpPr>
+          <p:cNvPr id="13" name="TextBox 13"/>
+          <p:cNvSpPr txBox="1"/>
+          <p:nvPr/>
+        </p:nvSpPr>
+        <p:spPr>
+          <a:xfrm>
+            <a:off x="685800" y="2465832"/>
+            <a:ext cx="594360" cy="320040"/>
+          </a:xfrm>
+          <a:prstGeom prst="rect">
+            <a:avLst/>
+          </a:prstGeom>
+        </p:spPr>
+        <p:txBody>
+          <a:bodyPr wrap="square" rtlCol="0">
+            <a:spAutoFit/>
+          </a:bodyPr>
+          <a:lstStyle/>
+          <a:p>
+            <a:r>
+              <a:rPr b="1" sz="1700" spc="60">
+                <a:solidFill>
+                  <a:srgbClr val="1746D1"/>
+                </a:solidFill>
+                <a:latin typeface="Aptos"/>
+              </a:rPr>
+              <a:t>01</a:t>
+            </a:r>
+          </a:p>
+        </p:txBody>
+      </p:sp>
+      <p:sp>
+        <p:nvSpPr>
+          <p:cNvPr id="14" name="TextBox 14"/>
+          <p:cNvSpPr txBox="1"/>
+          <p:nvPr/>
+        </p:nvSpPr>
+        <p:spPr>
+          <a:xfrm>
+            <a:off x="685800" y="3288792"/>
+            <a:ext cx="594360" cy="320040"/>
+          </a:xfrm>
+          <a:prstGeom prst="rect">
+            <a:avLst/>
+          </a:prstGeom>
+        </p:spPr>
+        <p:txBody>
+          <a:bodyPr wrap="square" rtlCol="0">
+            <a:spAutoFit/>
+          </a:bodyPr>
+          <a:lstStyle/>
+          <a:p>
+            <a:r>
+              <a:rPr b="1" sz="1700" spc="60">
+                <a:solidFill>
+                  <a:srgbClr val="1746D1"/>
+                </a:solidFill>
+                <a:latin typeface="Aptos"/>
+              </a:rPr>
+              <a:t>02</a:t>
+            </a:r>
+          </a:p>
+        </p:txBody>
+      </p:sp>
+      <p:sp>
+        <p:nvSpPr>
+          <p:cNvPr id="15" name="TextBox 15"/>
+          <p:cNvSpPr txBox="1"/>
+          <p:nvPr/>
+        </p:nvSpPr>
+        <p:spPr>
+          <a:xfrm>
+            <a:off x="685800" y="4111752"/>
+            <a:ext cx="594360" cy="320040"/>
+          </a:xfrm>
+          <a:prstGeom prst="rect">
+            <a:avLst/>
+          </a:prstGeom>
+        </p:spPr>
+        <p:txBody>
+          <a:bodyPr wrap="square" rtlCol="0">
+            <a:spAutoFit/>
+          </a:bodyPr>
+          <a:lstStyle/>
+          <a:p>
+            <a:r>
+              <a:rPr b="1" sz="1700" spc="60">
+                <a:solidFill>
+                  <a:srgbClr val="1746D1"/>
+                </a:solidFill>
+                <a:latin typeface="Aptos"/>
+              </a:rPr>
+              <a:t>03</a:t>
+            </a:r>
+          </a:p>
+        </p:txBody>
+      </p:sp>
+      <p:sp>
+        <p:nvSpPr>
+          <p:cNvPr id="16" name="Shape 16"/>
+          <p:cNvSpPr/>
+          <p:nvPr/>
+        </p:nvSpPr>
+        <p:spPr>
+          <a:xfrm>
+            <a:off x="685800" y="3063240"/>
+            <a:ext cx="7772400" cy="12700"/>
+          </a:xfrm>
+          <a:prstGeom prst="rect">
+            <a:avLst/>
+          </a:prstGeom>
+          <a:solidFill>
+            <a:srgbClr val="CFD8E8"/>
+          </a:solidFill>
+          <a:ln>
+            <a:noFill/>
+          </a:ln>
+        </p:spPr>
+        <p:txBody>
+          <a:bodyPr rtlCol="0" anchor="ctr"/>
+          <a:lstStyle/>
+          <a:p/>
+        </p:txBody>
+      </p:sp>
+      <p:sp>
+        <p:nvSpPr>
+          <p:cNvPr id="17" name="Shape 17"/>
+          <p:cNvSpPr/>
+          <p:nvPr/>
+        </p:nvSpPr>
+        <p:spPr>
+          <a:xfrm>
+            <a:off x="685800" y="3886200"/>
+            <a:ext cx="7772400" cy="12700"/>
+          </a:xfrm>
+          <a:prstGeom prst="rect">
+            <a:avLst/>
+          </a:prstGeom>
+          <a:solidFill>
+            <a:srgbClr val="CFD8E8"/>
+          </a:solidFill>
+          <a:ln>
+            <a:noFill/>
+          </a:ln>
+        </p:spPr>
+        <p:txBody>
+          <a:bodyPr rtlCol="0" anchor="ctr"/>
+          <a:lstStyle/>
+          <a:p/>
+        </p:txBody>
+      </p:sp>
+      <p:sp>
+        <p:nvSpPr>
+          <p:cNvPr id="18" name="Shape 18"/>
+          <p:cNvSpPr/>
+          <p:nvPr/>
+        </p:nvSpPr>
+        <p:spPr>
+          <a:xfrm>
+            <a:off x="685800" y="2011680"/>
+            <a:ext cx="594360" cy="54864"/>
+          </a:xfrm>
+          <a:prstGeom prst="rect">
+            <a:avLst/>
+          </a:prstGeom>
+          <a:solidFill>
+            <a:srgbClr val="E45A3E"/>
+          </a:solidFill>
+          <a:ln>
+            <a:noFill/>
+          </a:ln>
+        </p:spPr>
+        <p:txBody>
+          <a:bodyPr rtlCol="0" anchor="ctr"/>
+          <a:lstStyle/>
+          <a:p/>
         </p:txBody>
       </p:sp>
     </p:spTree>
@@ -8330,115 +9134,115 @@
         </p:nvSpPr>
         <p:spPr>
           <a:xfrm>
-            <a:off x="960120" y="365760"/>
-            <a:ext cx="5486400" cy="274320"/>
-          </a:xfrm>
-          <a:prstGeom prst="rect">
-            <a:avLst/>
-          </a:prstGeom>
-        </p:spPr>
-        <p:txBody>
-          <a:bodyPr wrap="square" rtlCol="0">
-            <a:spAutoFit/>
-          </a:bodyPr>
-          <a:lstStyle/>
-          <a:p>
-            <a:r>
-              <a:rPr b="1" sz="1200" spc="120">
+            <a:off x="960120" y="347472"/>
+            <a:ext cx="6858000" cy="310896"/>
+          </a:xfrm>
+          <a:prstGeom prst="rect">
+            <a:avLst/>
+          </a:prstGeom>
+        </p:spPr>
+        <p:txBody>
+          <a:bodyPr wrap="square" rtlCol="0">
+            <a:spAutoFit/>
+          </a:bodyPr>
+          <a:lstStyle/>
+          <a:p>
+            <a:r>
+              <a:rPr b="1" sz="1500" spc="240">
+                <a:solidFill>
+                  <a:srgbClr val="C53F25"/>
+                </a:solidFill>
+                <a:latin typeface="Aptos"/>
+              </a:rPr>
+              <a:t>COPILOT APP  /  DOCUMENTATION</a:t>
+            </a:r>
+          </a:p>
+        </p:txBody>
+      </p:sp>
+      <p:sp>
+        <p:nvSpPr>
+          <p:cNvPr id="6" name="TextBox 6"/>
+          <p:cNvSpPr txBox="1"/>
+          <p:nvPr/>
+        </p:nvSpPr>
+        <p:spPr>
+          <a:xfrm>
+            <a:off x="685800" y="754380"/>
+            <a:ext cx="7772400" cy="1188720"/>
+          </a:xfrm>
+          <a:prstGeom prst="rect">
+            <a:avLst/>
+          </a:prstGeom>
+        </p:spPr>
+        <p:txBody>
+          <a:bodyPr wrap="square" rtlCol="0">
+            <a:spAutoFit/>
+          </a:bodyPr>
+          <a:lstStyle/>
+          <a:p>
+            <a:r>
+              <a:rPr b="1" sz="4200" spc="-60">
+                <a:solidFill>
+                  <a:srgbClr val="172033"/>
+                </a:solidFill>
+                <a:latin typeface="Aptos Display"/>
+              </a:rPr>
+              <a:t>Keep exploring the Copilot app.</a:t>
+            </a:r>
+          </a:p>
+        </p:txBody>
+      </p:sp>
+      <p:sp>
+        <p:nvSpPr>
+          <p:cNvPr id="7" name="TextBox 7"/>
+          <p:cNvSpPr txBox="1"/>
+          <p:nvPr/>
+        </p:nvSpPr>
+        <p:spPr>
+          <a:xfrm>
+            <a:off x="1371600" y="2377440"/>
+            <a:ext cx="7086600" cy="792480"/>
+          </a:xfrm>
+          <a:prstGeom prst="rect">
+            <a:avLst/>
+          </a:prstGeom>
+        </p:spPr>
+        <p:txBody>
+          <a:bodyPr wrap="square" rtlCol="0">
+            <a:spAutoFit/>
+          </a:bodyPr>
+          <a:lstStyle/>
+          <a:p>
+            <a:r>
+              <a:rPr b="1" sz="2400">
+                <a:solidFill>
+                  <a:srgbClr val="172033"/>
+                </a:solidFill>
+                <a:latin typeface="Aptos"/>
+              </a:rPr>
+              <a:t>Copilot app overview</a:t>
+            </a:r>
+          </a:p>
+          <a:p>
+            <a:r>
+              <a:rPr b="1" sz="1600">
+                <a:solidFill>
+                  <a:srgbClr val="C53F25"/>
+                </a:solidFill>
+                <a:latin typeface="Aptos"/>
+              </a:rPr>
+              <a:t>docs.github.com/copilot/how-tos/github-copilot-app</a:t>
+            </a:r>
+          </a:p>
+          <a:p>
+            <a:r>
+              <a:rPr b="1" sz="600">
                 <a:solidFill>
                   <a:srgbClr val="1746D1"/>
                 </a:solidFill>
                 <a:latin typeface="Aptos"/>
               </a:rPr>
-              <a:t>COPILOT APP  /  DOCUMENTATION</a:t>
-            </a:r>
-          </a:p>
-        </p:txBody>
-      </p:sp>
-      <p:sp>
-        <p:nvSpPr>
-          <p:cNvPr id="6" name="TextBox 6"/>
-          <p:cNvSpPr txBox="1"/>
-          <p:nvPr/>
-        </p:nvSpPr>
-        <p:spPr>
-          <a:xfrm>
-            <a:off x="685800" y="868680"/>
-            <a:ext cx="7772400" cy="1005840"/>
-          </a:xfrm>
-          <a:prstGeom prst="rect">
-            <a:avLst/>
-          </a:prstGeom>
-        </p:spPr>
-        <p:txBody>
-          <a:bodyPr wrap="square" rtlCol="0">
-            <a:spAutoFit/>
-          </a:bodyPr>
-          <a:lstStyle/>
-          <a:p>
-            <a:r>
-              <a:rPr b="1" sz="3400" spc="-80">
-                <a:solidFill>
-                  <a:srgbClr val="172033"/>
-                </a:solidFill>
-                <a:latin typeface="Aptos Display"/>
-              </a:rPr>
-              <a:t>Keep exploring the Copilot app.</a:t>
-            </a:r>
-          </a:p>
-        </p:txBody>
-      </p:sp>
-      <p:sp>
-        <p:nvSpPr>
-          <p:cNvPr id="7" name="TextBox 7"/>
-          <p:cNvSpPr txBox="1"/>
-          <p:nvPr/>
-        </p:nvSpPr>
-        <p:spPr>
-          <a:xfrm>
-            <a:off x="685800" y="2103120"/>
-            <a:ext cx="7772400" cy="2377440"/>
-          </a:xfrm>
-          <a:prstGeom prst="rect">
-            <a:avLst/>
-          </a:prstGeom>
-        </p:spPr>
-        <p:txBody>
-          <a:bodyPr wrap="square" rtlCol="0">
-            <a:spAutoFit/>
-          </a:bodyPr>
-          <a:lstStyle/>
-          <a:p>
-            <a:r>
-              <a:rPr b="1" sz="1500">
-                <a:solidFill>
-                  <a:srgbClr val="1746D1"/>
-                </a:solidFill>
-                <a:latin typeface="Aptos"/>
-              </a:rPr>
-              <a:t>https://docs.github.com/copilot/how-tos/github-copilot-app</a:t>
-            </a:r>
-          </a:p>
-          <a:p>
-            <a:r>
-              <a:rPr b="1" sz="1500">
-                <a:solidFill>
-                  <a:srgbClr val="1746D1"/>
-                </a:solidFill>
-                <a:latin typeface="Aptos"/>
-              </a:rPr>
-              <a:t>https://docs.github.com/copilot/how-tos/github-copilot-app/agent-sessions</a:t>
-            </a:r>
-          </a:p>
-          <a:p>
-            <a:r>
-              <a:rPr b="1" sz="1500">
-                <a:solidFill>
-                  <a:srgbClr val="1746D1"/>
-                </a:solidFill>
-                <a:latin typeface="Aptos"/>
-              </a:rPr>
-              <a:t>https://docs.github.com/copilot/how-tos/github-copilot-app/managing-issues-and-pull-requests</a:t>
+              <a:t xml:space="preserve"> </a:t>
             </a:r>
           </a:p>
         </p:txBody>
@@ -8458,7 +9262,7 @@
             <a:avLst/>
           </a:prstGeom>
           <a:solidFill>
-            <a:srgbClr val="E8F0FF"/>
+            <a:srgbClr val="FFF3EF"/>
           </a:solidFill>
         </p:spPr>
         <p:txBody>
@@ -8466,81 +9270,349 @@
           <a:lstStyle/>
           <a:p>
             <a:r>
+              <a:rPr b="1" sz="1900">
+                <a:solidFill>
+                  <a:srgbClr val="C53F25"/>
+                </a:solidFill>
+                <a:latin typeface="Aptos"/>
+              </a:rPr>
+              <a:t>ALL LINKS  ·  aka.ms/ndc-oslo-copilot-workshop</a:t>
+            </a:r>
+          </a:p>
+        </p:txBody>
+      </p:sp>
+      <p:sp>
+        <p:nvSpPr>
+          <p:cNvPr id="9" name="TextBox 9"/>
+          <p:cNvSpPr txBox="1"/>
+          <p:nvPr/>
+        </p:nvSpPr>
+        <p:spPr>
+          <a:xfrm>
+            <a:off x="685800" y="6300216"/>
+            <a:ext cx="6858000" cy="320040"/>
+          </a:xfrm>
+          <a:prstGeom prst="rect">
+            <a:avLst/>
+          </a:prstGeom>
+        </p:spPr>
+        <p:txBody>
+          <a:bodyPr wrap="square" rtlCol="0">
+            <a:spAutoFit/>
+          </a:bodyPr>
+          <a:lstStyle/>
+          <a:p>
+            <a:r>
+              <a:rPr b="1" sz="1200" spc="120">
+                <a:solidFill>
+                  <a:srgbClr val="7A8497"/>
+                </a:solidFill>
+                <a:latin typeface="Aptos"/>
+              </a:rPr>
+              <a:t>NDC OSLO × GITHUB COPILOT WORKSHOP</a:t>
+            </a:r>
+          </a:p>
+        </p:txBody>
+      </p:sp>
+      <p:sp>
+        <p:nvSpPr>
+          <p:cNvPr id="10" name="TextBox 10"/>
+          <p:cNvSpPr txBox="1"/>
+          <p:nvPr/>
+        </p:nvSpPr>
+        <p:spPr>
+          <a:xfrm>
+            <a:off x="8046720" y="6300216"/>
+            <a:ext cx="640080" cy="320040"/>
+          </a:xfrm>
+          <a:prstGeom prst="rect">
+            <a:avLst/>
+          </a:prstGeom>
+        </p:spPr>
+        <p:txBody>
+          <a:bodyPr wrap="square" rtlCol="0">
+            <a:spAutoFit/>
+          </a:bodyPr>
+          <a:lstStyle/>
+          <a:p>
+            <a:r>
+              <a:rPr b="1" sz="1300">
+                <a:solidFill>
+                  <a:srgbClr val="C53F25"/>
+                </a:solidFill>
+                <a:latin typeface="Aptos"/>
+              </a:rPr>
+              <a:t>08</a:t>
+            </a:r>
+          </a:p>
+        </p:txBody>
+      </p:sp>
+      <p:sp>
+        <p:nvSpPr>
+          <p:cNvPr id="11" name="TextBox 11"/>
+          <p:cNvSpPr txBox="1"/>
+          <p:nvPr/>
+        </p:nvSpPr>
+        <p:spPr>
+          <a:xfrm>
+            <a:off x="1371600" y="3200400"/>
+            <a:ext cx="7086600" cy="792480"/>
+          </a:xfrm>
+          <a:prstGeom prst="rect">
+            <a:avLst/>
+          </a:prstGeom>
+        </p:spPr>
+        <p:txBody>
+          <a:bodyPr wrap="square" rtlCol="0">
+            <a:spAutoFit/>
+          </a:bodyPr>
+          <a:lstStyle/>
+          <a:p>
+            <a:r>
+              <a:rPr b="1" sz="2400">
+                <a:solidFill>
+                  <a:srgbClr val="172033"/>
+                </a:solidFill>
+                <a:latin typeface="Aptos"/>
+              </a:rPr>
+              <a:t>Agent sessions</a:t>
+            </a:r>
+          </a:p>
+          <a:p>
+            <a:r>
               <a:rPr b="1" sz="1600">
                 <a:solidFill>
-                  <a:srgbClr val="1746D1"/>
-                </a:solidFill>
-                <a:latin typeface="Aptos"/>
-              </a:rPr>
-              <a:t>CANVASES  ·  https://docs.github.com/copilot/how-tos/github-copilot-app/working-with-canvas-extensions</a:t>
-            </a:r>
-          </a:p>
-        </p:txBody>
-      </p:sp>
-      <p:sp>
-        <p:nvSpPr>
-          <p:cNvPr id="9" name="TextBox 9"/>
-          <p:cNvSpPr txBox="1"/>
-          <p:nvPr/>
-        </p:nvSpPr>
-        <p:spPr>
-          <a:xfrm>
-            <a:off x="685800" y="6355080"/>
-            <a:ext cx="6858000" cy="274320"/>
-          </a:xfrm>
-          <a:prstGeom prst="rect">
-            <a:avLst/>
-          </a:prstGeom>
-        </p:spPr>
-        <p:txBody>
-          <a:bodyPr wrap="square" rtlCol="0">
-            <a:spAutoFit/>
-          </a:bodyPr>
-          <a:lstStyle/>
-          <a:p>
-            <a:r>
-              <a:rPr b="1" sz="1000" spc="80">
-                <a:solidFill>
-                  <a:srgbClr val="7A8497"/>
-                </a:solidFill>
-                <a:latin typeface="Aptos"/>
-              </a:rPr>
-              <a:t>NDC OSLO × GITHUB COPILOT WORKSHOP</a:t>
-            </a:r>
-          </a:p>
-        </p:txBody>
-      </p:sp>
-      <p:sp>
-        <p:nvSpPr>
-          <p:cNvPr id="10" name="TextBox 10"/>
-          <p:cNvSpPr txBox="1"/>
-          <p:nvPr/>
-        </p:nvSpPr>
-        <p:spPr>
-          <a:xfrm>
-            <a:off x="8230000" y="6355080"/>
-            <a:ext cx="457200" cy="274320"/>
-          </a:xfrm>
-          <a:prstGeom prst="rect">
-            <a:avLst/>
-          </a:prstGeom>
-        </p:spPr>
-        <p:txBody>
-          <a:bodyPr wrap="square" rtlCol="0">
-            <a:spAutoFit/>
-          </a:bodyPr>
-          <a:lstStyle/>
-          <a:p>
-            <a:r>
-              <a:rPr b="1" sz="1000">
-                <a:solidFill>
-                  <a:srgbClr val="1746D1"/>
-                </a:solidFill>
-                <a:latin typeface="Aptos"/>
-              </a:rPr>
-              <a:t>08</a:t>
-            </a:r>
-          </a:p>
+                  <a:srgbClr val="C53F25"/>
+                </a:solidFill>
+                <a:latin typeface="Aptos"/>
+              </a:rPr>
+              <a:t>docs.github.com/copilot/how-tos/github-copilot-app/agent-sessions</a:t>
+            </a:r>
+          </a:p>
+        </p:txBody>
+      </p:sp>
+      <p:sp>
+        <p:nvSpPr>
+          <p:cNvPr id="12" name="TextBox 12"/>
+          <p:cNvSpPr txBox="1"/>
+          <p:nvPr/>
+        </p:nvSpPr>
+        <p:spPr>
+          <a:xfrm>
+            <a:off x="1371600" y="4023360"/>
+            <a:ext cx="7086600" cy="792480"/>
+          </a:xfrm>
+          <a:prstGeom prst="rect">
+            <a:avLst/>
+          </a:prstGeom>
+        </p:spPr>
+        <p:txBody>
+          <a:bodyPr wrap="square" rtlCol="0">
+            <a:spAutoFit/>
+          </a:bodyPr>
+          <a:lstStyle/>
+          <a:p>
+            <a:r>
+              <a:rPr b="1" sz="2400">
+                <a:solidFill>
+                  <a:srgbClr val="172033"/>
+                </a:solidFill>
+                <a:latin typeface="Aptos"/>
+              </a:rPr>
+              <a:t>Canvases, issues &amp; pull requests</a:t>
+            </a:r>
+          </a:p>
+          <a:p>
+            <a:r>
+              <a:rPr b="1" sz="1600">
+                <a:solidFill>
+                  <a:srgbClr val="C53F25"/>
+                </a:solidFill>
+                <a:latin typeface="Aptos"/>
+              </a:rPr>
+              <a:t>aka.ms/ndc-oslo-copilot-workshop  →  Resources</a:t>
+            </a:r>
+          </a:p>
+        </p:txBody>
+      </p:sp>
+      <p:sp>
+        <p:nvSpPr>
+          <p:cNvPr id="13" name="TextBox 13"/>
+          <p:cNvSpPr txBox="1"/>
+          <p:nvPr/>
+        </p:nvSpPr>
+        <p:spPr>
+          <a:xfrm>
+            <a:off x="685800" y="2465832"/>
+            <a:ext cx="594360" cy="320040"/>
+          </a:xfrm>
+          <a:prstGeom prst="rect">
+            <a:avLst/>
+          </a:prstGeom>
+        </p:spPr>
+        <p:txBody>
+          <a:bodyPr wrap="square" rtlCol="0">
+            <a:spAutoFit/>
+          </a:bodyPr>
+          <a:lstStyle/>
+          <a:p>
+            <a:r>
+              <a:rPr b="1" sz="1700" spc="60">
+                <a:solidFill>
+                  <a:srgbClr val="C53F25"/>
+                </a:solidFill>
+                <a:latin typeface="Aptos"/>
+              </a:rPr>
+              <a:t>01</a:t>
+            </a:r>
+          </a:p>
+        </p:txBody>
+      </p:sp>
+      <p:sp>
+        <p:nvSpPr>
+          <p:cNvPr id="14" name="TextBox 14"/>
+          <p:cNvSpPr txBox="1"/>
+          <p:nvPr/>
+        </p:nvSpPr>
+        <p:spPr>
+          <a:xfrm>
+            <a:off x="685800" y="3288792"/>
+            <a:ext cx="594360" cy="320040"/>
+          </a:xfrm>
+          <a:prstGeom prst="rect">
+            <a:avLst/>
+          </a:prstGeom>
+        </p:spPr>
+        <p:txBody>
+          <a:bodyPr wrap="square" rtlCol="0">
+            <a:spAutoFit/>
+          </a:bodyPr>
+          <a:lstStyle/>
+          <a:p>
+            <a:r>
+              <a:rPr b="1" sz="1700" spc="60">
+                <a:solidFill>
+                  <a:srgbClr val="C53F25"/>
+                </a:solidFill>
+                <a:latin typeface="Aptos"/>
+              </a:rPr>
+              <a:t>02</a:t>
+            </a:r>
+          </a:p>
+        </p:txBody>
+      </p:sp>
+      <p:sp>
+        <p:nvSpPr>
+          <p:cNvPr id="15" name="TextBox 15"/>
+          <p:cNvSpPr txBox="1"/>
+          <p:nvPr/>
+        </p:nvSpPr>
+        <p:spPr>
+          <a:xfrm>
+            <a:off x="685800" y="4111752"/>
+            <a:ext cx="594360" cy="320040"/>
+          </a:xfrm>
+          <a:prstGeom prst="rect">
+            <a:avLst/>
+          </a:prstGeom>
+        </p:spPr>
+        <p:txBody>
+          <a:bodyPr wrap="square" rtlCol="0">
+            <a:spAutoFit/>
+          </a:bodyPr>
+          <a:lstStyle/>
+          <a:p>
+            <a:r>
+              <a:rPr b="1" sz="1700" spc="60">
+                <a:solidFill>
+                  <a:srgbClr val="C53F25"/>
+                </a:solidFill>
+                <a:latin typeface="Aptos"/>
+              </a:rPr>
+              <a:t>03</a:t>
+            </a:r>
+          </a:p>
+        </p:txBody>
+      </p:sp>
+      <p:sp>
+        <p:nvSpPr>
+          <p:cNvPr id="16" name="Shape 16"/>
+          <p:cNvSpPr/>
+          <p:nvPr/>
+        </p:nvSpPr>
+        <p:spPr>
+          <a:xfrm>
+            <a:off x="685800" y="3063240"/>
+            <a:ext cx="7772400" cy="12700"/>
+          </a:xfrm>
+          <a:prstGeom prst="rect">
+            <a:avLst/>
+          </a:prstGeom>
+          <a:solidFill>
+            <a:srgbClr val="F0D7CF"/>
+          </a:solidFill>
+          <a:ln>
+            <a:noFill/>
+          </a:ln>
+        </p:spPr>
+        <p:txBody>
+          <a:bodyPr rtlCol="0" anchor="ctr"/>
+          <a:lstStyle/>
+          <a:p/>
+        </p:txBody>
+      </p:sp>
+      <p:sp>
+        <p:nvSpPr>
+          <p:cNvPr id="17" name="Shape 17"/>
+          <p:cNvSpPr/>
+          <p:nvPr/>
+        </p:nvSpPr>
+        <p:spPr>
+          <a:xfrm>
+            <a:off x="685800" y="3886200"/>
+            <a:ext cx="7772400" cy="12700"/>
+          </a:xfrm>
+          <a:prstGeom prst="rect">
+            <a:avLst/>
+          </a:prstGeom>
+          <a:solidFill>
+            <a:srgbClr val="F0D7CF"/>
+          </a:solidFill>
+          <a:ln>
+            <a:noFill/>
+          </a:ln>
+        </p:spPr>
+        <p:txBody>
+          <a:bodyPr rtlCol="0" anchor="ctr"/>
+          <a:lstStyle/>
+          <a:p/>
+        </p:txBody>
+      </p:sp>
+      <p:sp>
+        <p:nvSpPr>
+          <p:cNvPr id="18" name="Shape 18"/>
+          <p:cNvSpPr/>
+          <p:nvPr/>
+        </p:nvSpPr>
+        <p:spPr>
+          <a:xfrm>
+            <a:off x="685800" y="2011680"/>
+            <a:ext cx="594360" cy="54864"/>
+          </a:xfrm>
+          <a:prstGeom prst="rect">
+            <a:avLst/>
+          </a:prstGeom>
+          <a:solidFill>
+            <a:srgbClr val="E45A3E"/>
+          </a:solidFill>
+          <a:ln>
+            <a:noFill/>
+          </a:ln>
+        </p:spPr>
+        <p:txBody>
+          <a:bodyPr rtlCol="0" anchor="ctr"/>
+          <a:lstStyle/>
+          <a:p/>
         </p:txBody>
       </p:sp>
     </p:spTree>
@@ -8561,323 +9633,6 @@
         <p:nvPr/>
       </p:nvGrpSpPr>
       <p:grpSpPr/>
-      <p:sp>
-        <p:nvSpPr>
-          <p:cNvPr id="2" name="Shape 2"/>
-          <p:cNvSpPr/>
-          <p:nvPr/>
-        </p:nvSpPr>
-        <p:spPr>
-          <a:xfrm>
-            <a:off x="0" y="0"/>
-            <a:ext cx="137160" cy="6858000"/>
-          </a:xfrm>
-          <a:prstGeom prst="rect">
-            <a:avLst/>
-          </a:prstGeom>
-          <a:solidFill>
-            <a:srgbClr val="1746D1"/>
-          </a:solidFill>
-        </p:spPr>
-        <p:txBody>
-          <a:bodyPr rtlCol="0" anchor="ctr"/>
-          <a:lstStyle/>
-          <a:p/>
-        </p:txBody>
-      </p:sp>
-      <p:sp>
-        <p:nvSpPr>
-          <p:cNvPr id="3" name="Shape 3"/>
-          <p:cNvSpPr/>
-          <p:nvPr/>
-        </p:nvSpPr>
-        <p:spPr>
-          <a:xfrm>
-            <a:off x="685800" y="502920"/>
-            <a:ext cx="7772400" cy="45720"/>
-          </a:xfrm>
-          <a:prstGeom prst="rect">
-            <a:avLst/>
-          </a:prstGeom>
-          <a:solidFill>
-            <a:srgbClr val="CFD8E8"/>
-          </a:solidFill>
-        </p:spPr>
-        <p:txBody>
-          <a:bodyPr rtlCol="0" anchor="ctr"/>
-          <a:lstStyle/>
-          <a:p/>
-        </p:txBody>
-      </p:sp>
-      <p:sp>
-        <p:nvSpPr>
-          <p:cNvPr id="4" name="Shape 4"/>
-          <p:cNvSpPr/>
-          <p:nvPr/>
-        </p:nvSpPr>
-        <p:spPr>
-          <a:xfrm>
-            <a:off x="685800" y="411480"/>
-            <a:ext cx="182880" cy="182880"/>
-          </a:xfrm>
-          <a:prstGeom prst="ellipse">
-            <a:avLst/>
-          </a:prstGeom>
-          <a:solidFill>
-            <a:srgbClr val="E45A3E"/>
-          </a:solidFill>
-        </p:spPr>
-        <p:txBody>
-          <a:bodyPr rtlCol="0" anchor="ctr"/>
-          <a:lstStyle/>
-          <a:p/>
-        </p:txBody>
-      </p:sp>
-      <p:sp>
-        <p:nvSpPr>
-          <p:cNvPr id="5" name="TextBox 5"/>
-          <p:cNvSpPr txBox="1"/>
-          <p:nvPr/>
-        </p:nvSpPr>
-        <p:spPr>
-          <a:xfrm>
-            <a:off x="960120" y="365760"/>
-            <a:ext cx="5486400" cy="274320"/>
-          </a:xfrm>
-          <a:prstGeom prst="rect">
-            <a:avLst/>
-          </a:prstGeom>
-        </p:spPr>
-        <p:txBody>
-          <a:bodyPr wrap="square" rtlCol="0">
-            <a:spAutoFit/>
-          </a:bodyPr>
-          <a:lstStyle/>
-          <a:p>
-            <a:r>
-              <a:rPr b="1" sz="1200" spc="120">
-                <a:solidFill>
-                  <a:srgbClr val="1746D1"/>
-                </a:solidFill>
-                <a:latin typeface="Aptos"/>
-              </a:rPr>
-              <a:t>KEEP BUILDING</a:t>
-            </a:r>
-          </a:p>
-        </p:txBody>
-      </p:sp>
-      <p:sp>
-        <p:nvSpPr>
-          <p:cNvPr id="6" name="TextBox 6"/>
-          <p:cNvSpPr txBox="1"/>
-          <p:nvPr/>
-        </p:nvSpPr>
-        <p:spPr>
-          <a:xfrm>
-            <a:off x="685800" y="868680"/>
-            <a:ext cx="7772400" cy="1005840"/>
-          </a:xfrm>
-          <a:prstGeom prst="rect">
-            <a:avLst/>
-          </a:prstGeom>
-        </p:spPr>
-        <p:txBody>
-          <a:bodyPr wrap="square" rtlCol="0">
-            <a:spAutoFit/>
-          </a:bodyPr>
-          <a:lstStyle/>
-          <a:p>
-            <a:r>
-              <a:rPr b="1" sz="3400" spc="-80">
-                <a:solidFill>
-                  <a:srgbClr val="172033"/>
-                </a:solidFill>
-                <a:latin typeface="Aptos Display"/>
-              </a:rPr>
-              <a:t>Take the route home.</a:t>
-            </a:r>
-          </a:p>
-        </p:txBody>
-      </p:sp>
-      <p:sp>
-        <p:nvSpPr>
-          <p:cNvPr id="7" name="TextBox 7"/>
-          <p:cNvSpPr txBox="1"/>
-          <p:nvPr/>
-        </p:nvSpPr>
-        <p:spPr>
-          <a:xfrm>
-            <a:off x="685800" y="2103120"/>
-            <a:ext cx="4206240" cy="2377440"/>
-          </a:xfrm>
-          <a:prstGeom prst="rect">
-            <a:avLst/>
-          </a:prstGeom>
-        </p:spPr>
-        <p:txBody>
-          <a:bodyPr wrap="square" rtlCol="0">
-            <a:spAutoFit/>
-          </a:bodyPr>
-          <a:lstStyle/>
-          <a:p>
-            <a:r>
-              <a:rPr sz="2000">
-                <a:solidFill>
-                  <a:srgbClr val="455166"/>
-                </a:solidFill>
-                <a:latin typeface="Aptos"/>
-              </a:rPr>
-              <a:t>Revisit the workshop to finish lessons, repeat exercises, and follow the documentation.</a:t>
-            </a:r>
-          </a:p>
-          <a:p>
-            <a:r>
-              <a:rPr sz="2000">
-                <a:solidFill>
-                  <a:srgbClr val="455166"/>
-                </a:solidFill>
-                <a:latin typeface="Aptos"/>
-              </a:rPr>
-              <a:t>Share the workflows that worked—and the agent boundaries that made them trustworthy.</a:t>
-            </a:r>
-          </a:p>
-          <a:p>
-            <a:r>
-              <a:rPr sz="2000">
-                <a:solidFill>
-                  <a:srgbClr val="455166"/>
-                </a:solidFill>
-                <a:latin typeface="Aptos"/>
-              </a:rPr>
-              <a:t>Scan the code or use the short link to return at any time.</a:t>
-            </a:r>
-          </a:p>
-        </p:txBody>
-      </p:sp>
-      <p:sp>
-        <p:nvSpPr>
-          <p:cNvPr id="8" name="Shape 8"/>
-          <p:cNvSpPr/>
-          <p:nvPr/>
-        </p:nvSpPr>
-        <p:spPr>
-          <a:xfrm>
-            <a:off x="685800" y="4937760"/>
-            <a:ext cx="7772400" cy="914400"/>
-          </a:xfrm>
-          <a:prstGeom prst="roundRect">
-            <a:avLst/>
-          </a:prstGeom>
-          <a:solidFill>
-            <a:srgbClr val="E8F0FF"/>
-          </a:solidFill>
-        </p:spPr>
-        <p:txBody>
-          <a:bodyPr rtlCol="0" anchor="ctr"/>
-          <a:lstStyle/>
-          <a:p>
-            <a:r>
-              <a:rPr b="1" sz="1600">
-                <a:solidFill>
-                  <a:srgbClr val="1746D1"/>
-                </a:solidFill>
-                <a:latin typeface="Aptos"/>
-              </a:rPr>
-              <a:t>WORKSHOP  ·  https://aka.ms/ndc-oslo-copilot-workshop</a:t>
-            </a:r>
-          </a:p>
-        </p:txBody>
-      </p:sp>
-      <p:sp>
-        <p:nvSpPr>
-          <p:cNvPr id="9" name="TextBox 9"/>
-          <p:cNvSpPr txBox="1"/>
-          <p:nvPr/>
-        </p:nvSpPr>
-        <p:spPr>
-          <a:xfrm>
-            <a:off x="685800" y="6355080"/>
-            <a:ext cx="6858000" cy="274320"/>
-          </a:xfrm>
-          <a:prstGeom prst="rect">
-            <a:avLst/>
-          </a:prstGeom>
-        </p:spPr>
-        <p:txBody>
-          <a:bodyPr wrap="square" rtlCol="0">
-            <a:spAutoFit/>
-          </a:bodyPr>
-          <a:lstStyle/>
-          <a:p>
-            <a:r>
-              <a:rPr b="1" sz="1000" spc="80">
-                <a:solidFill>
-                  <a:srgbClr val="7A8497"/>
-                </a:solidFill>
-                <a:latin typeface="Aptos"/>
-              </a:rPr>
-              <a:t>NDC OSLO × GITHUB COPILOT WORKSHOP</a:t>
-            </a:r>
-          </a:p>
-        </p:txBody>
-      </p:sp>
-      <p:sp>
-        <p:nvSpPr>
-          <p:cNvPr id="10" name="TextBox 10"/>
-          <p:cNvSpPr txBox="1"/>
-          <p:nvPr/>
-        </p:nvSpPr>
-        <p:spPr>
-          <a:xfrm>
-            <a:off x="8230000" y="6355080"/>
-            <a:ext cx="457200" cy="274320"/>
-          </a:xfrm>
-          <a:prstGeom prst="rect">
-            <a:avLst/>
-          </a:prstGeom>
-        </p:spPr>
-        <p:txBody>
-          <a:bodyPr wrap="square" rtlCol="0">
-            <a:spAutoFit/>
-          </a:bodyPr>
-          <a:lstStyle/>
-          <a:p>
-            <a:r>
-              <a:rPr b="1" sz="1000">
-                <a:solidFill>
-                  <a:srgbClr val="1746D1"/>
-                </a:solidFill>
-                <a:latin typeface="Aptos"/>
-              </a:rPr>
-              <a:t>09</a:t>
-            </a:r>
-          </a:p>
-        </p:txBody>
-      </p:sp>
-      <p:sp>
-        <p:nvSpPr>
-          <p:cNvPr id="11" name="Shape 11"/>
-          <p:cNvSpPr/>
-          <p:nvPr/>
-        </p:nvSpPr>
-        <p:spPr>
-          <a:xfrm>
-            <a:off x="5257800" y="1143000"/>
-            <a:ext cx="3200400" cy="3657600"/>
-          </a:xfrm>
-          <a:prstGeom prst="roundRect">
-            <a:avLst/>
-          </a:prstGeom>
-          <a:solidFill>
-            <a:srgbClr val="E8F0FF"/>
-          </a:solidFill>
-        </p:spPr>
-        <p:txBody>
-          <a:bodyPr rtlCol="0" anchor="ctr"/>
-          <a:lstStyle/>
-          <a:p/>
-        </p:txBody>
-      </p:sp>
       <p:pic>
         <p:nvPicPr>
           <p:cNvPr id="12" name="Picture 12"/>
@@ -8902,6 +9657,323 @@
           </a:prstGeom>
         </p:spPr>
       </p:pic>
+      <p:sp>
+        <p:nvSpPr>
+          <p:cNvPr id="2" name="Shape 2"/>
+          <p:cNvSpPr/>
+          <p:nvPr/>
+        </p:nvSpPr>
+        <p:spPr>
+          <a:xfrm>
+            <a:off x="0" y="0"/>
+            <a:ext cx="137160" cy="6858000"/>
+          </a:xfrm>
+          <a:prstGeom prst="rect">
+            <a:avLst/>
+          </a:prstGeom>
+          <a:solidFill>
+            <a:srgbClr val="1746D1"/>
+          </a:solidFill>
+        </p:spPr>
+        <p:txBody>
+          <a:bodyPr rtlCol="0" anchor="ctr"/>
+          <a:lstStyle/>
+          <a:p/>
+        </p:txBody>
+      </p:sp>
+      <p:sp>
+        <p:nvSpPr>
+          <p:cNvPr id="3" name="Shape 3"/>
+          <p:cNvSpPr/>
+          <p:nvPr/>
+        </p:nvSpPr>
+        <p:spPr>
+          <a:xfrm>
+            <a:off x="685800" y="502920"/>
+            <a:ext cx="7772400" cy="45720"/>
+          </a:xfrm>
+          <a:prstGeom prst="rect">
+            <a:avLst/>
+          </a:prstGeom>
+          <a:solidFill>
+            <a:srgbClr val="CFD8E8"/>
+          </a:solidFill>
+        </p:spPr>
+        <p:txBody>
+          <a:bodyPr rtlCol="0" anchor="ctr"/>
+          <a:lstStyle/>
+          <a:p/>
+        </p:txBody>
+      </p:sp>
+      <p:sp>
+        <p:nvSpPr>
+          <p:cNvPr id="4" name="Shape 4"/>
+          <p:cNvSpPr/>
+          <p:nvPr/>
+        </p:nvSpPr>
+        <p:spPr>
+          <a:xfrm>
+            <a:off x="685800" y="411480"/>
+            <a:ext cx="182880" cy="182880"/>
+          </a:xfrm>
+          <a:prstGeom prst="ellipse">
+            <a:avLst/>
+          </a:prstGeom>
+          <a:solidFill>
+            <a:srgbClr val="E45A3E"/>
+          </a:solidFill>
+        </p:spPr>
+        <p:txBody>
+          <a:bodyPr rtlCol="0" anchor="ctr"/>
+          <a:lstStyle/>
+          <a:p/>
+        </p:txBody>
+      </p:sp>
+      <p:sp>
+        <p:nvSpPr>
+          <p:cNvPr id="5" name="TextBox 5"/>
+          <p:cNvSpPr txBox="1"/>
+          <p:nvPr/>
+        </p:nvSpPr>
+        <p:spPr>
+          <a:xfrm>
+            <a:off x="960120" y="347472"/>
+            <a:ext cx="6858000" cy="310896"/>
+          </a:xfrm>
+          <a:prstGeom prst="rect">
+            <a:avLst/>
+          </a:prstGeom>
+        </p:spPr>
+        <p:txBody>
+          <a:bodyPr wrap="square" rtlCol="0">
+            <a:spAutoFit/>
+          </a:bodyPr>
+          <a:lstStyle/>
+          <a:p>
+            <a:r>
+              <a:rPr b="1" sz="1500" spc="240">
+                <a:solidFill>
+                  <a:srgbClr val="1746D1"/>
+                </a:solidFill>
+                <a:latin typeface="Aptos"/>
+              </a:rPr>
+              <a:t>KEEP BUILDING</a:t>
+            </a:r>
+          </a:p>
+        </p:txBody>
+      </p:sp>
+      <p:sp>
+        <p:nvSpPr>
+          <p:cNvPr id="6" name="TextBox 6"/>
+          <p:cNvSpPr txBox="1"/>
+          <p:nvPr/>
+        </p:nvSpPr>
+        <p:spPr>
+          <a:xfrm>
+            <a:off x="685800" y="754380"/>
+            <a:ext cx="4572000" cy="1280160"/>
+          </a:xfrm>
+          <a:prstGeom prst="rect">
+            <a:avLst/>
+          </a:prstGeom>
+        </p:spPr>
+        <p:txBody>
+          <a:bodyPr wrap="square" rtlCol="0">
+            <a:spAutoFit/>
+          </a:bodyPr>
+          <a:lstStyle/>
+          <a:p>
+            <a:r>
+              <a:rPr b="1" sz="3600" spc="-60">
+                <a:solidFill>
+                  <a:srgbClr val="172033"/>
+                </a:solidFill>
+                <a:latin typeface="Aptos Display"/>
+              </a:rPr>
+              <a:t>Take the route home.</a:t>
+            </a:r>
+          </a:p>
+        </p:txBody>
+      </p:sp>
+      <p:sp>
+        <p:nvSpPr>
+          <p:cNvPr id="7" name="TextBox 7"/>
+          <p:cNvSpPr txBox="1"/>
+          <p:nvPr/>
+        </p:nvSpPr>
+        <p:spPr>
+          <a:xfrm>
+            <a:off x="685800" y="2286000"/>
+            <a:ext cx="4206240" cy="2377440"/>
+          </a:xfrm>
+          <a:prstGeom prst="rect">
+            <a:avLst/>
+          </a:prstGeom>
+        </p:spPr>
+        <p:txBody>
+          <a:bodyPr wrap="square" rtlCol="0">
+            <a:spAutoFit/>
+          </a:bodyPr>
+          <a:lstStyle/>
+          <a:p>
+            <a:r>
+              <a:rPr sz="2000">
+                <a:solidFill>
+                  <a:srgbClr val="455166"/>
+                </a:solidFill>
+                <a:latin typeface="Aptos"/>
+              </a:rPr>
+              <a:t>Finish the lessons at your own pace.</a:t>
+            </a:r>
+          </a:p>
+          <a:p>
+            <a:r>
+              <a:rPr sz="2000">
+                <a:solidFill>
+                  <a:srgbClr val="455166"/>
+                </a:solidFill>
+                <a:latin typeface="Aptos"/>
+              </a:rPr>
+              <a:t>Repeat the exercises on your own repos.</a:t>
+            </a:r>
+          </a:p>
+          <a:p>
+            <a:r>
+              <a:rPr sz="2000">
+                <a:solidFill>
+                  <a:srgbClr val="455166"/>
+                </a:solidFill>
+                <a:latin typeface="Aptos"/>
+              </a:rPr>
+              <a:t>Scan to return at any time.</a:t>
+            </a:r>
+          </a:p>
+        </p:txBody>
+      </p:sp>
+      <p:sp>
+        <p:nvSpPr>
+          <p:cNvPr id="8" name="Shape 8"/>
+          <p:cNvSpPr/>
+          <p:nvPr/>
+        </p:nvSpPr>
+        <p:spPr>
+          <a:xfrm>
+            <a:off x="685800" y="4937760"/>
+            <a:ext cx="7772400" cy="914400"/>
+          </a:xfrm>
+          <a:prstGeom prst="roundRect">
+            <a:avLst/>
+          </a:prstGeom>
+          <a:solidFill>
+            <a:srgbClr val="E8F0FF"/>
+          </a:solidFill>
+        </p:spPr>
+        <p:txBody>
+          <a:bodyPr rtlCol="0" anchor="ctr"/>
+          <a:lstStyle/>
+          <a:p>
+            <a:r>
+              <a:rPr b="1" sz="1900">
+                <a:solidFill>
+                  <a:srgbClr val="1746D1"/>
+                </a:solidFill>
+                <a:latin typeface="Aptos"/>
+              </a:rPr>
+              <a:t>WORKSHOP  ·  aka.ms/ndc-oslo-copilot-workshop</a:t>
+            </a:r>
+          </a:p>
+        </p:txBody>
+      </p:sp>
+      <p:sp>
+        <p:nvSpPr>
+          <p:cNvPr id="9" name="TextBox 9"/>
+          <p:cNvSpPr txBox="1"/>
+          <p:nvPr/>
+        </p:nvSpPr>
+        <p:spPr>
+          <a:xfrm>
+            <a:off x="685800" y="6300216"/>
+            <a:ext cx="6858000" cy="320040"/>
+          </a:xfrm>
+          <a:prstGeom prst="rect">
+            <a:avLst/>
+          </a:prstGeom>
+        </p:spPr>
+        <p:txBody>
+          <a:bodyPr wrap="square" rtlCol="0">
+            <a:spAutoFit/>
+          </a:bodyPr>
+          <a:lstStyle/>
+          <a:p>
+            <a:r>
+              <a:rPr b="1" sz="1200" spc="120">
+                <a:solidFill>
+                  <a:srgbClr val="7A8497"/>
+                </a:solidFill>
+                <a:latin typeface="Aptos"/>
+              </a:rPr>
+              <a:t>NDC OSLO × GITHUB COPILOT WORKSHOP</a:t>
+            </a:r>
+          </a:p>
+        </p:txBody>
+      </p:sp>
+      <p:sp>
+        <p:nvSpPr>
+          <p:cNvPr id="10" name="TextBox 10"/>
+          <p:cNvSpPr txBox="1"/>
+          <p:nvPr/>
+        </p:nvSpPr>
+        <p:spPr>
+          <a:xfrm>
+            <a:off x="8046720" y="6300216"/>
+            <a:ext cx="640080" cy="320040"/>
+          </a:xfrm>
+          <a:prstGeom prst="rect">
+            <a:avLst/>
+          </a:prstGeom>
+        </p:spPr>
+        <p:txBody>
+          <a:bodyPr wrap="square" rtlCol="0">
+            <a:spAutoFit/>
+          </a:bodyPr>
+          <a:lstStyle/>
+          <a:p>
+            <a:r>
+              <a:rPr b="1" sz="1300">
+                <a:solidFill>
+                  <a:srgbClr val="1746D1"/>
+                </a:solidFill>
+                <a:latin typeface="Aptos"/>
+              </a:rPr>
+              <a:t>09</a:t>
+            </a:r>
+          </a:p>
+        </p:txBody>
+      </p:sp>
+      <p:sp>
+        <p:nvSpPr>
+          <p:cNvPr id="11" name="Shape 11"/>
+          <p:cNvSpPr/>
+          <p:nvPr/>
+        </p:nvSpPr>
+        <p:spPr>
+          <a:xfrm>
+            <a:off x="5257800" y="1143000"/>
+            <a:ext cx="3200400" cy="3657600"/>
+          </a:xfrm>
+          <a:prstGeom prst="roundRect">
+            <a:avLst/>
+          </a:prstGeom>
+          <a:solidFill>
+            <a:srgbClr val="E8F0FF"/>
+          </a:solidFill>
+        </p:spPr>
+        <p:txBody>
+          <a:bodyPr rtlCol="0" anchor="ctr"/>
+          <a:lstStyle/>
+          <a:p/>
+        </p:txBody>
+      </p:sp>
       <p:pic>
         <p:nvPicPr>
           <p:cNvPr id="13" name="Picture 13"/>
@@ -8926,6 +9998,66 @@
           </a:prstGeom>
         </p:spPr>
       </p:pic>
+      <p:sp>
+        <p:nvSpPr>
+          <p:cNvPr id="14" name="Shape 14"/>
+          <p:cNvSpPr/>
+          <p:nvPr/>
+        </p:nvSpPr>
+        <p:spPr>
+          <a:xfrm>
+            <a:off x="685800" y="2011680"/>
+            <a:ext cx="594360" cy="54864"/>
+          </a:xfrm>
+          <a:prstGeom prst="rect">
+            <a:avLst/>
+          </a:prstGeom>
+          <a:solidFill>
+            <a:srgbClr val="E45A3E"/>
+          </a:solidFill>
+          <a:ln>
+            <a:noFill/>
+          </a:ln>
+        </p:spPr>
+        <p:txBody>
+          <a:bodyPr rtlCol="0" anchor="ctr"/>
+          <a:lstStyle/>
+          <a:p/>
+        </p:txBody>
+      </p:sp>
+      <p:sp>
+        <p:nvSpPr>
+          <p:cNvPr id="15" name="TextBox 15"/>
+          <p:cNvSpPr txBox="1"/>
+          <p:nvPr/>
+        </p:nvSpPr>
+        <p:spPr>
+          <a:xfrm>
+            <a:off x="5669280" y="4114800"/>
+            <a:ext cx="2423160" cy="320040"/>
+          </a:xfrm>
+          <a:prstGeom prst="rect">
+            <a:avLst/>
+          </a:prstGeom>
+        </p:spPr>
+        <p:txBody>
+          <a:bodyPr wrap="square" rtlCol="0">
+            <a:spAutoFit/>
+          </a:bodyPr>
+          <a:lstStyle/>
+          <a:p>
+            <a:r>
+              <a:rPr b="1" sz="1400" spc="200">
+                <a:solidFill>
+                  <a:srgbClr val="1746D1"/>
+                </a:solidFill>
+                <a:latin typeface="Aptos"/>
+              </a:rPr>
+              <a:t>SCAN TO RETURN</a:t>
+            </a:r>
+          </a:p>
+        </p:txBody>
+      </p:sp>
     </p:spTree>
   </p:cSld>
   <p:clrMapOvr>
@@ -9255,323 +10387,6 @@
         <p:nvPr/>
       </p:nvGrpSpPr>
       <p:grpSpPr/>
-      <p:sp>
-        <p:nvSpPr>
-          <p:cNvPr id="2" name="Shape 2"/>
-          <p:cNvSpPr/>
-          <p:nvPr/>
-        </p:nvSpPr>
-        <p:spPr>
-          <a:xfrm>
-            <a:off x="0" y="0"/>
-            <a:ext cx="137160" cy="6858000"/>
-          </a:xfrm>
-          <a:prstGeom prst="rect">
-            <a:avLst/>
-          </a:prstGeom>
-          <a:solidFill>
-            <a:srgbClr val="1746D1"/>
-          </a:solidFill>
-        </p:spPr>
-        <p:txBody>
-          <a:bodyPr rtlCol="0" anchor="ctr"/>
-          <a:lstStyle/>
-          <a:p/>
-        </p:txBody>
-      </p:sp>
-      <p:sp>
-        <p:nvSpPr>
-          <p:cNvPr id="3" name="Shape 3"/>
-          <p:cNvSpPr/>
-          <p:nvPr/>
-        </p:nvSpPr>
-        <p:spPr>
-          <a:xfrm>
-            <a:off x="685800" y="502920"/>
-            <a:ext cx="7772400" cy="45720"/>
-          </a:xfrm>
-          <a:prstGeom prst="rect">
-            <a:avLst/>
-          </a:prstGeom>
-          <a:solidFill>
-            <a:srgbClr val="CFD8E8"/>
-          </a:solidFill>
-        </p:spPr>
-        <p:txBody>
-          <a:bodyPr rtlCol="0" anchor="ctr"/>
-          <a:lstStyle/>
-          <a:p/>
-        </p:txBody>
-      </p:sp>
-      <p:sp>
-        <p:nvSpPr>
-          <p:cNvPr id="4" name="Shape 4"/>
-          <p:cNvSpPr/>
-          <p:nvPr/>
-        </p:nvSpPr>
-        <p:spPr>
-          <a:xfrm>
-            <a:off x="685800" y="411480"/>
-            <a:ext cx="182880" cy="182880"/>
-          </a:xfrm>
-          <a:prstGeom prst="ellipse">
-            <a:avLst/>
-          </a:prstGeom>
-          <a:solidFill>
-            <a:srgbClr val="E45A3E"/>
-          </a:solidFill>
-        </p:spPr>
-        <p:txBody>
-          <a:bodyPr rtlCol="0" anchor="ctr"/>
-          <a:lstStyle/>
-          <a:p/>
-        </p:txBody>
-      </p:sp>
-      <p:sp>
-        <p:nvSpPr>
-          <p:cNvPr id="5" name="TextBox 5"/>
-          <p:cNvSpPr txBox="1"/>
-          <p:nvPr/>
-        </p:nvSpPr>
-        <p:spPr>
-          <a:xfrm>
-            <a:off x="960120" y="365760"/>
-            <a:ext cx="5486400" cy="274320"/>
-          </a:xfrm>
-          <a:prstGeom prst="rect">
-            <a:avLst/>
-          </a:prstGeom>
-        </p:spPr>
-        <p:txBody>
-          <a:bodyPr wrap="square" rtlCol="0">
-            <a:spAutoFit/>
-          </a:bodyPr>
-          <a:lstStyle/>
-          <a:p>
-            <a:r>
-              <a:rPr b="1" sz="1200" spc="120">
-                <a:solidFill>
-                  <a:srgbClr val="1746D1"/>
-                </a:solidFill>
-                <a:latin typeface="Aptos"/>
-              </a:rPr>
-              <a:t>START HERE</a:t>
-            </a:r>
-          </a:p>
-        </p:txBody>
-      </p:sp>
-      <p:sp>
-        <p:nvSpPr>
-          <p:cNvPr id="6" name="TextBox 6"/>
-          <p:cNvSpPr txBox="1"/>
-          <p:nvPr/>
-        </p:nvSpPr>
-        <p:spPr>
-          <a:xfrm>
-            <a:off x="685800" y="868680"/>
-            <a:ext cx="7772400" cy="1005840"/>
-          </a:xfrm>
-          <a:prstGeom prst="rect">
-            <a:avLst/>
-          </a:prstGeom>
-        </p:spPr>
-        <p:txBody>
-          <a:bodyPr wrap="square" rtlCol="0">
-            <a:spAutoFit/>
-          </a:bodyPr>
-          <a:lstStyle/>
-          <a:p>
-            <a:r>
-              <a:rPr b="1" sz="3400" spc="-80">
-                <a:solidFill>
-                  <a:srgbClr val="172033"/>
-                </a:solidFill>
-                <a:latin typeface="Aptos Display"/>
-              </a:rPr>
-              <a:t>Scan once. Keep this route open.</a:t>
-            </a:r>
-          </a:p>
-        </p:txBody>
-      </p:sp>
-      <p:sp>
-        <p:nvSpPr>
-          <p:cNvPr id="7" name="TextBox 7"/>
-          <p:cNvSpPr txBox="1"/>
-          <p:nvPr/>
-        </p:nvSpPr>
-        <p:spPr>
-          <a:xfrm>
-            <a:off x="685800" y="2103120"/>
-            <a:ext cx="4206240" cy="2377440"/>
-          </a:xfrm>
-          <a:prstGeom prst="rect">
-            <a:avLst/>
-          </a:prstGeom>
-        </p:spPr>
-        <p:txBody>
-          <a:bodyPr wrap="square" rtlCol="0">
-            <a:spAutoFit/>
-          </a:bodyPr>
-          <a:lstStyle/>
-          <a:p>
-            <a:r>
-              <a:rPr sz="2000">
-                <a:solidFill>
-                  <a:srgbClr val="455166"/>
-                </a:solidFill>
-                <a:latin typeface="Aptos"/>
-              </a:rPr>
-              <a:t>Preparation, both labs, lesson order, resources, and browser-saved progress.</a:t>
-            </a:r>
-          </a:p>
-          <a:p>
-            <a:r>
-              <a:rPr sz="2000">
-                <a:solidFill>
-                  <a:srgbClr val="455166"/>
-                </a:solidFill>
-                <a:latin typeface="Aptos"/>
-              </a:rPr>
-              <a:t>Open the workshop on your laptop before we begin.</a:t>
-            </a:r>
-          </a:p>
-          <a:p>
-            <a:r>
-              <a:rPr sz="2000">
-                <a:solidFill>
-                  <a:srgbClr val="455166"/>
-                </a:solidFill>
-                <a:latin typeface="Aptos"/>
-              </a:rPr>
-              <a:t>Use the same route whenever you need to resume.</a:t>
-            </a:r>
-          </a:p>
-        </p:txBody>
-      </p:sp>
-      <p:sp>
-        <p:nvSpPr>
-          <p:cNvPr id="8" name="Shape 8"/>
-          <p:cNvSpPr/>
-          <p:nvPr/>
-        </p:nvSpPr>
-        <p:spPr>
-          <a:xfrm>
-            <a:off x="685800" y="4937760"/>
-            <a:ext cx="7772400" cy="914400"/>
-          </a:xfrm>
-          <a:prstGeom prst="roundRect">
-            <a:avLst/>
-          </a:prstGeom>
-          <a:solidFill>
-            <a:srgbClr val="E8F0FF"/>
-          </a:solidFill>
-        </p:spPr>
-        <p:txBody>
-          <a:bodyPr rtlCol="0" anchor="ctr"/>
-          <a:lstStyle/>
-          <a:p>
-            <a:r>
-              <a:rPr b="1" sz="1600">
-                <a:solidFill>
-                  <a:srgbClr val="1746D1"/>
-                </a:solidFill>
-                <a:latin typeface="Aptos"/>
-              </a:rPr>
-              <a:t>WORKSHOP  ·  https://aka.ms/ndc-oslo-copilot-workshop</a:t>
-            </a:r>
-          </a:p>
-        </p:txBody>
-      </p:sp>
-      <p:sp>
-        <p:nvSpPr>
-          <p:cNvPr id="9" name="TextBox 9"/>
-          <p:cNvSpPr txBox="1"/>
-          <p:nvPr/>
-        </p:nvSpPr>
-        <p:spPr>
-          <a:xfrm>
-            <a:off x="685800" y="6355080"/>
-            <a:ext cx="6858000" cy="274320"/>
-          </a:xfrm>
-          <a:prstGeom prst="rect">
-            <a:avLst/>
-          </a:prstGeom>
-        </p:spPr>
-        <p:txBody>
-          <a:bodyPr wrap="square" rtlCol="0">
-            <a:spAutoFit/>
-          </a:bodyPr>
-          <a:lstStyle/>
-          <a:p>
-            <a:r>
-              <a:rPr b="1" sz="1000" spc="80">
-                <a:solidFill>
-                  <a:srgbClr val="7A8497"/>
-                </a:solidFill>
-                <a:latin typeface="Aptos"/>
-              </a:rPr>
-              <a:t>NDC OSLO × GITHUB COPILOT WORKSHOP</a:t>
-            </a:r>
-          </a:p>
-        </p:txBody>
-      </p:sp>
-      <p:sp>
-        <p:nvSpPr>
-          <p:cNvPr id="10" name="TextBox 10"/>
-          <p:cNvSpPr txBox="1"/>
-          <p:nvPr/>
-        </p:nvSpPr>
-        <p:spPr>
-          <a:xfrm>
-            <a:off x="8230000" y="6355080"/>
-            <a:ext cx="457200" cy="274320"/>
-          </a:xfrm>
-          <a:prstGeom prst="rect">
-            <a:avLst/>
-          </a:prstGeom>
-        </p:spPr>
-        <p:txBody>
-          <a:bodyPr wrap="square" rtlCol="0">
-            <a:spAutoFit/>
-          </a:bodyPr>
-          <a:lstStyle/>
-          <a:p>
-            <a:r>
-              <a:rPr b="1" sz="1000">
-                <a:solidFill>
-                  <a:srgbClr val="1746D1"/>
-                </a:solidFill>
-                <a:latin typeface="Aptos"/>
-              </a:rPr>
-              <a:t>03</a:t>
-            </a:r>
-          </a:p>
-        </p:txBody>
-      </p:sp>
-      <p:sp>
-        <p:nvSpPr>
-          <p:cNvPr id="11" name="Shape 11"/>
-          <p:cNvSpPr/>
-          <p:nvPr/>
-        </p:nvSpPr>
-        <p:spPr>
-          <a:xfrm>
-            <a:off x="5257800" y="1143000"/>
-            <a:ext cx="3200400" cy="3657600"/>
-          </a:xfrm>
-          <a:prstGeom prst="roundRect">
-            <a:avLst/>
-          </a:prstGeom>
-          <a:solidFill>
-            <a:srgbClr val="E8F0FF"/>
-          </a:solidFill>
-        </p:spPr>
-        <p:txBody>
-          <a:bodyPr rtlCol="0" anchor="ctr"/>
-          <a:lstStyle/>
-          <a:p/>
-        </p:txBody>
-      </p:sp>
       <p:pic>
         <p:nvPicPr>
           <p:cNvPr id="12" name="Picture 12"/>
@@ -9596,6 +10411,323 @@
           </a:prstGeom>
         </p:spPr>
       </p:pic>
+      <p:sp>
+        <p:nvSpPr>
+          <p:cNvPr id="2" name="Shape 2"/>
+          <p:cNvSpPr/>
+          <p:nvPr/>
+        </p:nvSpPr>
+        <p:spPr>
+          <a:xfrm>
+            <a:off x="0" y="0"/>
+            <a:ext cx="137160" cy="6858000"/>
+          </a:xfrm>
+          <a:prstGeom prst="rect">
+            <a:avLst/>
+          </a:prstGeom>
+          <a:solidFill>
+            <a:srgbClr val="1746D1"/>
+          </a:solidFill>
+        </p:spPr>
+        <p:txBody>
+          <a:bodyPr rtlCol="0" anchor="ctr"/>
+          <a:lstStyle/>
+          <a:p/>
+        </p:txBody>
+      </p:sp>
+      <p:sp>
+        <p:nvSpPr>
+          <p:cNvPr id="3" name="Shape 3"/>
+          <p:cNvSpPr/>
+          <p:nvPr/>
+        </p:nvSpPr>
+        <p:spPr>
+          <a:xfrm>
+            <a:off x="685800" y="502920"/>
+            <a:ext cx="7772400" cy="45720"/>
+          </a:xfrm>
+          <a:prstGeom prst="rect">
+            <a:avLst/>
+          </a:prstGeom>
+          <a:solidFill>
+            <a:srgbClr val="CFD8E8"/>
+          </a:solidFill>
+        </p:spPr>
+        <p:txBody>
+          <a:bodyPr rtlCol="0" anchor="ctr"/>
+          <a:lstStyle/>
+          <a:p/>
+        </p:txBody>
+      </p:sp>
+      <p:sp>
+        <p:nvSpPr>
+          <p:cNvPr id="4" name="Shape 4"/>
+          <p:cNvSpPr/>
+          <p:nvPr/>
+        </p:nvSpPr>
+        <p:spPr>
+          <a:xfrm>
+            <a:off x="685800" y="411480"/>
+            <a:ext cx="182880" cy="182880"/>
+          </a:xfrm>
+          <a:prstGeom prst="ellipse">
+            <a:avLst/>
+          </a:prstGeom>
+          <a:solidFill>
+            <a:srgbClr val="E45A3E"/>
+          </a:solidFill>
+        </p:spPr>
+        <p:txBody>
+          <a:bodyPr rtlCol="0" anchor="ctr"/>
+          <a:lstStyle/>
+          <a:p/>
+        </p:txBody>
+      </p:sp>
+      <p:sp>
+        <p:nvSpPr>
+          <p:cNvPr id="5" name="TextBox 5"/>
+          <p:cNvSpPr txBox="1"/>
+          <p:nvPr/>
+        </p:nvSpPr>
+        <p:spPr>
+          <a:xfrm>
+            <a:off x="960120" y="347472"/>
+            <a:ext cx="6858000" cy="310896"/>
+          </a:xfrm>
+          <a:prstGeom prst="rect">
+            <a:avLst/>
+          </a:prstGeom>
+        </p:spPr>
+        <p:txBody>
+          <a:bodyPr wrap="square" rtlCol="0">
+            <a:spAutoFit/>
+          </a:bodyPr>
+          <a:lstStyle/>
+          <a:p>
+            <a:r>
+              <a:rPr b="1" sz="1500" spc="240">
+                <a:solidFill>
+                  <a:srgbClr val="1746D1"/>
+                </a:solidFill>
+                <a:latin typeface="Aptos"/>
+              </a:rPr>
+              <a:t>START HERE</a:t>
+            </a:r>
+          </a:p>
+        </p:txBody>
+      </p:sp>
+      <p:sp>
+        <p:nvSpPr>
+          <p:cNvPr id="6" name="TextBox 6"/>
+          <p:cNvSpPr txBox="1"/>
+          <p:nvPr/>
+        </p:nvSpPr>
+        <p:spPr>
+          <a:xfrm>
+            <a:off x="685800" y="754380"/>
+            <a:ext cx="4572000" cy="1280160"/>
+          </a:xfrm>
+          <a:prstGeom prst="rect">
+            <a:avLst/>
+          </a:prstGeom>
+        </p:spPr>
+        <p:txBody>
+          <a:bodyPr wrap="square" rtlCol="0">
+            <a:spAutoFit/>
+          </a:bodyPr>
+          <a:lstStyle/>
+          <a:p>
+            <a:r>
+              <a:rPr b="1" sz="3600" spc="-60">
+                <a:solidFill>
+                  <a:srgbClr val="172033"/>
+                </a:solidFill>
+                <a:latin typeface="Aptos Display"/>
+              </a:rPr>
+              <a:t>Scan once. Keep it open.</a:t>
+            </a:r>
+          </a:p>
+        </p:txBody>
+      </p:sp>
+      <p:sp>
+        <p:nvSpPr>
+          <p:cNvPr id="7" name="TextBox 7"/>
+          <p:cNvSpPr txBox="1"/>
+          <p:nvPr/>
+        </p:nvSpPr>
+        <p:spPr>
+          <a:xfrm>
+            <a:off x="685800" y="2286000"/>
+            <a:ext cx="4206240" cy="2377440"/>
+          </a:xfrm>
+          <a:prstGeom prst="rect">
+            <a:avLst/>
+          </a:prstGeom>
+        </p:spPr>
+        <p:txBody>
+          <a:bodyPr wrap="square" rtlCol="0">
+            <a:spAutoFit/>
+          </a:bodyPr>
+          <a:lstStyle/>
+          <a:p>
+            <a:r>
+              <a:rPr sz="2000">
+                <a:solidFill>
+                  <a:srgbClr val="455166"/>
+                </a:solidFill>
+                <a:latin typeface="Aptos"/>
+              </a:rPr>
+              <a:t>Preparation, both labs, resources.</a:t>
+            </a:r>
+          </a:p>
+          <a:p>
+            <a:r>
+              <a:rPr sz="2000">
+                <a:solidFill>
+                  <a:srgbClr val="455166"/>
+                </a:solidFill>
+                <a:latin typeface="Aptos"/>
+              </a:rPr>
+              <a:t>Open it on your laptop before we begin.</a:t>
+            </a:r>
+          </a:p>
+          <a:p>
+            <a:r>
+              <a:rPr sz="2000">
+                <a:solidFill>
+                  <a:srgbClr val="455166"/>
+                </a:solidFill>
+                <a:latin typeface="Aptos"/>
+              </a:rPr>
+              <a:t>Progress saves in your browser.</a:t>
+            </a:r>
+          </a:p>
+        </p:txBody>
+      </p:sp>
+      <p:sp>
+        <p:nvSpPr>
+          <p:cNvPr id="8" name="Shape 8"/>
+          <p:cNvSpPr/>
+          <p:nvPr/>
+        </p:nvSpPr>
+        <p:spPr>
+          <a:xfrm>
+            <a:off x="685800" y="4937760"/>
+            <a:ext cx="7772400" cy="914400"/>
+          </a:xfrm>
+          <a:prstGeom prst="roundRect">
+            <a:avLst/>
+          </a:prstGeom>
+          <a:solidFill>
+            <a:srgbClr val="E8F0FF"/>
+          </a:solidFill>
+        </p:spPr>
+        <p:txBody>
+          <a:bodyPr rtlCol="0" anchor="ctr"/>
+          <a:lstStyle/>
+          <a:p>
+            <a:r>
+              <a:rPr b="1" sz="1900">
+                <a:solidFill>
+                  <a:srgbClr val="1746D1"/>
+                </a:solidFill>
+                <a:latin typeface="Aptos"/>
+              </a:rPr>
+              <a:t>WORKSHOP  ·  aka.ms/ndc-oslo-copilot-workshop</a:t>
+            </a:r>
+          </a:p>
+        </p:txBody>
+      </p:sp>
+      <p:sp>
+        <p:nvSpPr>
+          <p:cNvPr id="9" name="TextBox 9"/>
+          <p:cNvSpPr txBox="1"/>
+          <p:nvPr/>
+        </p:nvSpPr>
+        <p:spPr>
+          <a:xfrm>
+            <a:off x="685800" y="6300216"/>
+            <a:ext cx="6858000" cy="320040"/>
+          </a:xfrm>
+          <a:prstGeom prst="rect">
+            <a:avLst/>
+          </a:prstGeom>
+        </p:spPr>
+        <p:txBody>
+          <a:bodyPr wrap="square" rtlCol="0">
+            <a:spAutoFit/>
+          </a:bodyPr>
+          <a:lstStyle/>
+          <a:p>
+            <a:r>
+              <a:rPr b="1" sz="1200" spc="120">
+                <a:solidFill>
+                  <a:srgbClr val="7A8497"/>
+                </a:solidFill>
+                <a:latin typeface="Aptos"/>
+              </a:rPr>
+              <a:t>NDC OSLO × GITHUB COPILOT WORKSHOP</a:t>
+            </a:r>
+          </a:p>
+        </p:txBody>
+      </p:sp>
+      <p:sp>
+        <p:nvSpPr>
+          <p:cNvPr id="10" name="TextBox 10"/>
+          <p:cNvSpPr txBox="1"/>
+          <p:nvPr/>
+        </p:nvSpPr>
+        <p:spPr>
+          <a:xfrm>
+            <a:off x="8046720" y="6300216"/>
+            <a:ext cx="640080" cy="320040"/>
+          </a:xfrm>
+          <a:prstGeom prst="rect">
+            <a:avLst/>
+          </a:prstGeom>
+        </p:spPr>
+        <p:txBody>
+          <a:bodyPr wrap="square" rtlCol="0">
+            <a:spAutoFit/>
+          </a:bodyPr>
+          <a:lstStyle/>
+          <a:p>
+            <a:r>
+              <a:rPr b="1" sz="1300">
+                <a:solidFill>
+                  <a:srgbClr val="1746D1"/>
+                </a:solidFill>
+                <a:latin typeface="Aptos"/>
+              </a:rPr>
+              <a:t>03</a:t>
+            </a:r>
+          </a:p>
+        </p:txBody>
+      </p:sp>
+      <p:sp>
+        <p:nvSpPr>
+          <p:cNvPr id="11" name="Shape 11"/>
+          <p:cNvSpPr/>
+          <p:nvPr/>
+        </p:nvSpPr>
+        <p:spPr>
+          <a:xfrm>
+            <a:off x="5257800" y="1143000"/>
+            <a:ext cx="3200400" cy="3657600"/>
+          </a:xfrm>
+          <a:prstGeom prst="roundRect">
+            <a:avLst/>
+          </a:prstGeom>
+          <a:solidFill>
+            <a:srgbClr val="E8F0FF"/>
+          </a:solidFill>
+        </p:spPr>
+        <p:txBody>
+          <a:bodyPr rtlCol="0" anchor="ctr"/>
+          <a:lstStyle/>
+          <a:p/>
+        </p:txBody>
+      </p:sp>
       <p:pic>
         <p:nvPicPr>
           <p:cNvPr id="13" name="Picture 13"/>
@@ -9620,6 +10752,66 @@
           </a:prstGeom>
         </p:spPr>
       </p:pic>
+      <p:sp>
+        <p:nvSpPr>
+          <p:cNvPr id="14" name="Shape 14"/>
+          <p:cNvSpPr/>
+          <p:nvPr/>
+        </p:nvSpPr>
+        <p:spPr>
+          <a:xfrm>
+            <a:off x="685800" y="2011680"/>
+            <a:ext cx="594360" cy="54864"/>
+          </a:xfrm>
+          <a:prstGeom prst="rect">
+            <a:avLst/>
+          </a:prstGeom>
+          <a:solidFill>
+            <a:srgbClr val="E45A3E"/>
+          </a:solidFill>
+          <a:ln>
+            <a:noFill/>
+          </a:ln>
+        </p:spPr>
+        <p:txBody>
+          <a:bodyPr rtlCol="0" anchor="ctr"/>
+          <a:lstStyle/>
+          <a:p/>
+        </p:txBody>
+      </p:sp>
+      <p:sp>
+        <p:nvSpPr>
+          <p:cNvPr id="15" name="TextBox 15"/>
+          <p:cNvSpPr txBox="1"/>
+          <p:nvPr/>
+        </p:nvSpPr>
+        <p:spPr>
+          <a:xfrm>
+            <a:off x="5669280" y="4114800"/>
+            <a:ext cx="2423160" cy="320040"/>
+          </a:xfrm>
+          <a:prstGeom prst="rect">
+            <a:avLst/>
+          </a:prstGeom>
+        </p:spPr>
+        <p:txBody>
+          <a:bodyPr wrap="square" rtlCol="0">
+            <a:spAutoFit/>
+          </a:bodyPr>
+          <a:lstStyle/>
+          <a:p>
+            <a:r>
+              <a:rPr b="1" sz="1400" spc="200">
+                <a:solidFill>
+                  <a:srgbClr val="1746D1"/>
+                </a:solidFill>
+                <a:latin typeface="Aptos"/>
+              </a:rPr>
+              <a:t>SCAN TO OPEN</a:t>
+            </a:r>
+          </a:p>
+        </p:txBody>
+      </p:sp>
     </p:spTree>
   </p:cSld>
   <p:clrMapOvr>
@@ -9718,23 +10910,23 @@
         </p:nvSpPr>
         <p:spPr>
           <a:xfrm>
-            <a:off x="960120" y="365760"/>
-            <a:ext cx="5486400" cy="274320"/>
-          </a:xfrm>
-          <a:prstGeom prst="rect">
-            <a:avLst/>
-          </a:prstGeom>
-        </p:spPr>
-        <p:txBody>
-          <a:bodyPr wrap="square" rtlCol="0">
-            <a:spAutoFit/>
-          </a:bodyPr>
-          <a:lstStyle/>
-          <a:p>
-            <a:r>
-              <a:rPr b="1" sz="1200" spc="120">
-                <a:solidFill>
-                  <a:srgbClr val="1746D1"/>
+            <a:off x="960120" y="347472"/>
+            <a:ext cx="6858000" cy="310896"/>
+          </a:xfrm>
+          <a:prstGeom prst="rect">
+            <a:avLst/>
+          </a:prstGeom>
+        </p:spPr>
+        <p:txBody>
+          <a:bodyPr wrap="square" rtlCol="0">
+            <a:spAutoFit/>
+          </a:bodyPr>
+          <a:lstStyle/>
+          <a:p>
+            <a:r>
+              <a:rPr b="1" sz="1500" spc="240">
+                <a:solidFill>
+                  <a:srgbClr val="C53F25"/>
                 </a:solidFill>
                 <a:latin typeface="Aptos"/>
               </a:rPr>
@@ -9751,21 +10943,21 @@
         </p:nvSpPr>
         <p:spPr>
           <a:xfrm>
-            <a:off x="685800" y="868680"/>
-            <a:ext cx="7772400" cy="1005840"/>
-          </a:xfrm>
-          <a:prstGeom prst="rect">
-            <a:avLst/>
-          </a:prstGeom>
-        </p:spPr>
-        <p:txBody>
-          <a:bodyPr wrap="square" rtlCol="0">
-            <a:spAutoFit/>
-          </a:bodyPr>
-          <a:lstStyle/>
-          <a:p>
-            <a:r>
-              <a:rPr b="1" sz="3400" spc="-80">
+            <a:off x="685800" y="754380"/>
+            <a:ext cx="7772400" cy="1188720"/>
+          </a:xfrm>
+          <a:prstGeom prst="rect">
+            <a:avLst/>
+          </a:prstGeom>
+        </p:spPr>
+        <p:txBody>
+          <a:bodyPr wrap="square" rtlCol="0">
+            <a:spAutoFit/>
+          </a:bodyPr>
+          <a:lstStyle/>
+          <a:p>
+            <a:r>
+              <a:rPr b="1" sz="4200" spc="-60">
                 <a:solidFill>
                   <a:srgbClr val="172033"/>
                 </a:solidFill>
@@ -9784,32 +10976,32 @@
         </p:nvSpPr>
         <p:spPr>
           <a:xfrm>
-            <a:off x="685800" y="2103120"/>
-            <a:ext cx="7772400" cy="1645920"/>
-          </a:xfrm>
-          <a:prstGeom prst="rect">
-            <a:avLst/>
-          </a:prstGeom>
-        </p:spPr>
-        <p:txBody>
-          <a:bodyPr wrap="square" rtlCol="0">
-            <a:spAutoFit/>
-          </a:bodyPr>
-          <a:lstStyle/>
-          <a:p>
-            <a:r>
-              <a:rPr sz="2000">
+            <a:off x="685800" y="2194560"/>
+            <a:ext cx="7772400" cy="1371600"/>
+          </a:xfrm>
+          <a:prstGeom prst="rect">
+            <a:avLst/>
+          </a:prstGeom>
+        </p:spPr>
+        <p:txBody>
+          <a:bodyPr wrap="square" rtlCol="0">
+            <a:spAutoFit/>
+          </a:bodyPr>
+          <a:lstStyle/>
+          <a:p>
+            <a:r>
+              <a:rPr sz="2200">
                 <a:solidFill>
                   <a:srgbClr val="455166"/>
                 </a:solidFill>
                 <a:latin typeface="Aptos"/>
               </a:rPr>
-              <a:t>Use the workshop redemption code provided by the presenters.</a:t>
-            </a:r>
-          </a:p>
-          <a:p>
-            <a:r>
-              <a:rPr sz="2000">
+              <a:t>Use the redemption code shown by the presenters.</a:t>
+            </a:r>
+          </a:p>
+          <a:p>
+            <a:r>
+              <a:rPr sz="2200">
                 <a:solidFill>
                   <a:srgbClr val="455166"/>
                 </a:solidFill>
@@ -9820,13 +11012,13 @@
           </a:p>
           <a:p>
             <a:r>
-              <a:rPr sz="2000">
+              <a:rPr sz="2200">
                 <a:solidFill>
                   <a:srgbClr val="455166"/>
                 </a:solidFill>
                 <a:latin typeface="Aptos"/>
               </a:rPr>
-              <a:t>Enter the code at github.com/redeem and follow the confirmation flow.</a:t>
+              <a:t>Enter it at github.com/redeem and confirm.</a:t>
             </a:r>
           </a:p>
         </p:txBody>
@@ -9846,7 +11038,7 @@
             <a:avLst/>
           </a:prstGeom>
           <a:solidFill>
-            <a:srgbClr val="E8F0FF"/>
+            <a:srgbClr val="FFF3EF"/>
           </a:solidFill>
         </p:spPr>
         <p:txBody>
@@ -9854,13 +11046,13 @@
           <a:lstStyle/>
           <a:p>
             <a:r>
-              <a:rPr b="1" sz="1600">
-                <a:solidFill>
-                  <a:srgbClr val="1746D1"/>
-                </a:solidFill>
-                <a:latin typeface="Aptos"/>
-              </a:rPr>
-              <a:t>REDEEM  ·  https://github.com/redeem</a:t>
+              <a:rPr b="1" sz="1900">
+                <a:solidFill>
+                  <a:srgbClr val="C53F25"/>
+                </a:solidFill>
+                <a:latin typeface="Aptos"/>
+              </a:rPr>
+              <a:t>REDEEM  ·  github.com/redeem</a:t>
             </a:r>
           </a:p>
         </p:txBody>
@@ -9873,21 +11065,21 @@
         </p:nvSpPr>
         <p:spPr>
           <a:xfrm>
-            <a:off x="685800" y="6355080"/>
-            <a:ext cx="6858000" cy="274320"/>
-          </a:xfrm>
-          <a:prstGeom prst="rect">
-            <a:avLst/>
-          </a:prstGeom>
-        </p:spPr>
-        <p:txBody>
-          <a:bodyPr wrap="square" rtlCol="0">
-            <a:spAutoFit/>
-          </a:bodyPr>
-          <a:lstStyle/>
-          <a:p>
-            <a:r>
-              <a:rPr b="1" sz="1000" spc="80">
+            <a:off x="685800" y="6300216"/>
+            <a:ext cx="6858000" cy="320040"/>
+          </a:xfrm>
+          <a:prstGeom prst="rect">
+            <a:avLst/>
+          </a:prstGeom>
+        </p:spPr>
+        <p:txBody>
+          <a:bodyPr wrap="square" rtlCol="0">
+            <a:spAutoFit/>
+          </a:bodyPr>
+          <a:lstStyle/>
+          <a:p>
+            <a:r>
+              <a:rPr b="1" sz="1200" spc="120">
                 <a:solidFill>
                   <a:srgbClr val="7A8497"/>
                 </a:solidFill>
@@ -9906,23 +11098,23 @@
         </p:nvSpPr>
         <p:spPr>
           <a:xfrm>
-            <a:off x="8230000" y="6355080"/>
-            <a:ext cx="457200" cy="274320"/>
-          </a:xfrm>
-          <a:prstGeom prst="rect">
-            <a:avLst/>
-          </a:prstGeom>
-        </p:spPr>
-        <p:txBody>
-          <a:bodyPr wrap="square" rtlCol="0">
-            <a:spAutoFit/>
-          </a:bodyPr>
-          <a:lstStyle/>
-          <a:p>
-            <a:r>
-              <a:rPr b="1" sz="1000">
-                <a:solidFill>
-                  <a:srgbClr val="1746D1"/>
+            <a:off x="8046720" y="6300216"/>
+            <a:ext cx="640080" cy="320040"/>
+          </a:xfrm>
+          <a:prstGeom prst="rect">
+            <a:avLst/>
+          </a:prstGeom>
+        </p:spPr>
+        <p:txBody>
+          <a:bodyPr wrap="square" rtlCol="0">
+            <a:spAutoFit/>
+          </a:bodyPr>
+          <a:lstStyle/>
+          <a:p>
+            <a:r>
+              <a:rPr b="1" sz="1300">
+                <a:solidFill>
+                  <a:srgbClr val="C53F25"/>
                 </a:solidFill>
                 <a:latin typeface="Aptos"/>
               </a:rPr>
@@ -9939,8 +11131,8 @@
         </p:nvSpPr>
         <p:spPr>
           <a:xfrm>
-            <a:off x="685800" y="3886200"/>
-            <a:ext cx="7772400" cy="822960"/>
+            <a:off x="685800" y="3749040"/>
+            <a:ext cx="7772400" cy="960120"/>
           </a:xfrm>
           <a:prstGeom prst="roundRect">
             <a:avLst/>
@@ -9959,15 +11151,42 @@
           <a:lstStyle/>
           <a:p>
             <a:r>
-              <a:rPr b="1" sz="2400" spc="150">
+              <a:rPr b="1" sz="3000" spc="120">
                 <a:solidFill>
                   <a:srgbClr val="C53F25"/>
                 </a:solidFill>
-                <a:latin typeface="Aptos Display"/>
-              </a:rPr>
-              <a:t>[ ADD REDEMPTION CODE ]</a:t>
-            </a:r>
-          </a:p>
+                <a:latin typeface="Aptos"/>
+              </a:rPr>
+              <a:t>[    ADD REDEMPTION CODE    ]</a:t>
+            </a:r>
+          </a:p>
+        </p:txBody>
+      </p:sp>
+      <p:sp>
+        <p:nvSpPr>
+          <p:cNvPr id="12" name="Shape 12"/>
+          <p:cNvSpPr/>
+          <p:nvPr/>
+        </p:nvSpPr>
+        <p:spPr>
+          <a:xfrm>
+            <a:off x="685800" y="2011680"/>
+            <a:ext cx="594360" cy="54864"/>
+          </a:xfrm>
+          <a:prstGeom prst="rect">
+            <a:avLst/>
+          </a:prstGeom>
+          <a:solidFill>
+            <a:srgbClr val="E45A3E"/>
+          </a:solidFill>
+          <a:ln>
+            <a:noFill/>
+          </a:ln>
+        </p:spPr>
+        <p:txBody>
+          <a:bodyPr rtlCol="0" anchor="ctr"/>
+          <a:lstStyle/>
+          <a:p/>
         </p:txBody>
       </p:sp>
     </p:spTree>
@@ -10379,21 +11598,21 @@
         </p:nvSpPr>
         <p:spPr>
           <a:xfrm>
-            <a:off x="960120" y="365760"/>
-            <a:ext cx="5486400" cy="274320"/>
-          </a:xfrm>
-          <a:prstGeom prst="rect">
-            <a:avLst/>
-          </a:prstGeom>
-        </p:spPr>
-        <p:txBody>
-          <a:bodyPr wrap="square" rtlCol="0">
-            <a:spAutoFit/>
-          </a:bodyPr>
-          <a:lstStyle/>
-          <a:p>
-            <a:r>
-              <a:rPr b="1" sz="1200" spc="120">
+            <a:off x="960120" y="347472"/>
+            <a:ext cx="6858000" cy="310896"/>
+          </a:xfrm>
+          <a:prstGeom prst="rect">
+            <a:avLst/>
+          </a:prstGeom>
+        </p:spPr>
+        <p:txBody>
+          <a:bodyPr wrap="square" rtlCol="0">
+            <a:spAutoFit/>
+          </a:bodyPr>
+          <a:lstStyle/>
+          <a:p>
+            <a:r>
+              <a:rPr b="1" sz="1500" spc="240">
                 <a:solidFill>
                   <a:srgbClr val="1746D1"/>
                 </a:solidFill>
@@ -10412,27 +11631,27 @@
         </p:nvSpPr>
         <p:spPr>
           <a:xfrm>
-            <a:off x="685800" y="868680"/>
-            <a:ext cx="7772400" cy="1005840"/>
-          </a:xfrm>
-          <a:prstGeom prst="rect">
-            <a:avLst/>
-          </a:prstGeom>
-        </p:spPr>
-        <p:txBody>
-          <a:bodyPr wrap="square" rtlCol="0">
-            <a:spAutoFit/>
-          </a:bodyPr>
-          <a:lstStyle/>
-          <a:p>
-            <a:r>
-              <a:rPr b="1" sz="3400" spc="-80">
+            <a:off x="685800" y="754380"/>
+            <a:ext cx="7772400" cy="1188720"/>
+          </a:xfrm>
+          <a:prstGeom prst="rect">
+            <a:avLst/>
+          </a:prstGeom>
+        </p:spPr>
+        <p:txBody>
+          <a:bodyPr wrap="square" rtlCol="0">
+            <a:spAutoFit/>
+          </a:bodyPr>
+          <a:lstStyle/>
+          <a:p>
+            <a:r>
+              <a:rPr b="1" sz="4200" spc="-60">
                 <a:solidFill>
                   <a:srgbClr val="172033"/>
                 </a:solidFill>
                 <a:latin typeface="Aptos Display"/>
               </a:rPr>
-              <a:t>VS Code lab: what we'll do</a:t>
+              <a:t>What we’ll do in VS Code</a:t>
             </a:r>
           </a:p>
         </p:txBody>
@@ -10445,49 +11664,49 @@
         </p:nvSpPr>
         <p:spPr>
           <a:xfrm>
-            <a:off x="685800" y="2103120"/>
-            <a:ext cx="7772400" cy="2377440"/>
-          </a:xfrm>
-          <a:prstGeom prst="rect">
-            <a:avLst/>
-          </a:prstGeom>
-        </p:spPr>
-        <p:txBody>
-          <a:bodyPr wrap="square" rtlCol="0">
-            <a:spAutoFit/>
-          </a:bodyPr>
-          <a:lstStyle/>
-          <a:p>
-            <a:r>
-              <a:rPr sz="2000">
+            <a:off x="1371600" y="2377440"/>
+            <a:ext cx="7086600" cy="792480"/>
+          </a:xfrm>
+          <a:prstGeom prst="rect">
+            <a:avLst/>
+          </a:prstGeom>
+        </p:spPr>
+        <p:txBody>
+          <a:bodyPr wrap="square" rtlCol="0">
+            <a:spAutoFit/>
+          </a:bodyPr>
+          <a:lstStyle/>
+          <a:p>
+            <a:r>
+              <a:rPr b="1" sz="2400">
+                <a:solidFill>
+                  <a:srgbClr val="172033"/>
+                </a:solidFill>
+                <a:latin typeface="Aptos"/>
+              </a:rPr>
+              <a:t>Engineer the context</a:t>
+            </a:r>
+          </a:p>
+          <a:p>
+            <a:r>
+              <a:rPr sz="1700">
                 <a:solidFill>
                   <a:srgbClr val="455166"/>
                 </a:solidFill>
                 <a:latin typeface="Aptos"/>
               </a:rPr>
-              <a:t>Engineer context  ·  /setup, /init, dogfooding, and reusable skills.</a:t>
-            </a:r>
-          </a:p>
-          <a:p>
-            <a:r>
-              <a:rPr sz="2000">
+              <a:t>/setup, /init, dogfooding, and reusable custom skills.</a:t>
+            </a:r>
+          </a:p>
+          <a:p>
+            <a:r>
+              <a:rPr sz="600">
                 <a:solidFill>
                   <a:srgbClr val="455166"/>
                 </a:solidFill>
                 <a:latin typeface="Aptos"/>
               </a:rPr>
-              <a:t>Design in Plan mode  ·  comment on real UI  ·  preserve design instructions.</a:t>
-            </a:r>
-          </a:p>
-          <a:p>
-            <a:r>
-              <a:rPr sz="2000">
-                <a:solidFill>
-                  <a:srgbClr val="455166"/>
-                </a:solidFill>
-                <a:latin typeface="Aptos"/>
-              </a:rPr>
-              <a:t>Orchestrate Quiz Master, Pixel Jam, TDD, hooks, debug logs, and UX review.</a:t>
+              <a:t xml:space="preserve"> </a:t>
             </a:r>
           </a:p>
         </p:txBody>
@@ -10515,13 +11734,13 @@
           <a:lstStyle/>
           <a:p>
             <a:r>
-              <a:rPr b="1" sz="1600">
+              <a:rPr b="1" sz="1900">
                 <a:solidFill>
                   <a:srgbClr val="1746D1"/>
                 </a:solidFill>
                 <a:latin typeface="Aptos"/>
               </a:rPr>
-              <a:t>BUILD  ·  Redesign and extend Bingo Mixer while making agent behavior observable.</a:t>
+              <a:t>BUILD  ·  Extend Bingo Mixer with observable agent behavior.</a:t>
             </a:r>
           </a:p>
         </p:txBody>
@@ -10534,21 +11753,21 @@
         </p:nvSpPr>
         <p:spPr>
           <a:xfrm>
-            <a:off x="685800" y="6355080"/>
-            <a:ext cx="6858000" cy="274320"/>
-          </a:xfrm>
-          <a:prstGeom prst="rect">
-            <a:avLst/>
-          </a:prstGeom>
-        </p:spPr>
-        <p:txBody>
-          <a:bodyPr wrap="square" rtlCol="0">
-            <a:spAutoFit/>
-          </a:bodyPr>
-          <a:lstStyle/>
-          <a:p>
-            <a:r>
-              <a:rPr b="1" sz="1000" spc="80">
+            <a:off x="685800" y="6300216"/>
+            <a:ext cx="6858000" cy="320040"/>
+          </a:xfrm>
+          <a:prstGeom prst="rect">
+            <a:avLst/>
+          </a:prstGeom>
+        </p:spPr>
+        <p:txBody>
+          <a:bodyPr wrap="square" rtlCol="0">
+            <a:spAutoFit/>
+          </a:bodyPr>
+          <a:lstStyle/>
+          <a:p>
+            <a:r>
+              <a:rPr b="1" sz="1200" spc="120">
                 <a:solidFill>
                   <a:srgbClr val="7A8497"/>
                 </a:solidFill>
@@ -10567,21 +11786,21 @@
         </p:nvSpPr>
         <p:spPr>
           <a:xfrm>
-            <a:off x="8230000" y="6355080"/>
-            <a:ext cx="457200" cy="274320"/>
-          </a:xfrm>
-          <a:prstGeom prst="rect">
-            <a:avLst/>
-          </a:prstGeom>
-        </p:spPr>
-        <p:txBody>
-          <a:bodyPr wrap="square" rtlCol="0">
-            <a:spAutoFit/>
-          </a:bodyPr>
-          <a:lstStyle/>
-          <a:p>
-            <a:r>
-              <a:rPr b="1" sz="1000">
+            <a:off x="8046720" y="6300216"/>
+            <a:ext cx="640080" cy="320040"/>
+          </a:xfrm>
+          <a:prstGeom prst="rect">
+            <a:avLst/>
+          </a:prstGeom>
+        </p:spPr>
+        <p:txBody>
+          <a:bodyPr wrap="square" rtlCol="0">
+            <a:spAutoFit/>
+          </a:bodyPr>
+          <a:lstStyle/>
+          <a:p>
+            <a:r>
+              <a:rPr b="1" sz="1300">
                 <a:solidFill>
                   <a:srgbClr val="1746D1"/>
                 </a:solidFill>
@@ -10590,6 +11809,274 @@
               <a:t>05</a:t>
             </a:r>
           </a:p>
+        </p:txBody>
+      </p:sp>
+      <p:sp>
+        <p:nvSpPr>
+          <p:cNvPr id="11" name="TextBox 11"/>
+          <p:cNvSpPr txBox="1"/>
+          <p:nvPr/>
+        </p:nvSpPr>
+        <p:spPr>
+          <a:xfrm>
+            <a:off x="1371600" y="3200400"/>
+            <a:ext cx="7086600" cy="792480"/>
+          </a:xfrm>
+          <a:prstGeom prst="rect">
+            <a:avLst/>
+          </a:prstGeom>
+        </p:spPr>
+        <p:txBody>
+          <a:bodyPr wrap="square" rtlCol="0">
+            <a:spAutoFit/>
+          </a:bodyPr>
+          <a:lstStyle/>
+          <a:p>
+            <a:r>
+              <a:rPr b="1" sz="2400">
+                <a:solidFill>
+                  <a:srgbClr val="172033"/>
+                </a:solidFill>
+                <a:latin typeface="Aptos"/>
+              </a:rPr>
+              <a:t>Design in Plan mode</a:t>
+            </a:r>
+          </a:p>
+          <a:p>
+            <a:r>
+              <a:rPr sz="1700">
+                <a:solidFill>
+                  <a:srgbClr val="455166"/>
+                </a:solidFill>
+                <a:latin typeface="Aptos"/>
+              </a:rPr>
+              <a:t>Comment on real UI and keep your design instructions.</a:t>
+            </a:r>
+          </a:p>
+        </p:txBody>
+      </p:sp>
+      <p:sp>
+        <p:nvSpPr>
+          <p:cNvPr id="12" name="TextBox 12"/>
+          <p:cNvSpPr txBox="1"/>
+          <p:nvPr/>
+        </p:nvSpPr>
+        <p:spPr>
+          <a:xfrm>
+            <a:off x="1371600" y="4023360"/>
+            <a:ext cx="7086600" cy="792480"/>
+          </a:xfrm>
+          <a:prstGeom prst="rect">
+            <a:avLst/>
+          </a:prstGeom>
+        </p:spPr>
+        <p:txBody>
+          <a:bodyPr wrap="square" rtlCol="0">
+            <a:spAutoFit/>
+          </a:bodyPr>
+          <a:lstStyle/>
+          <a:p>
+            <a:r>
+              <a:rPr b="1" sz="2400">
+                <a:solidFill>
+                  <a:srgbClr val="172033"/>
+                </a:solidFill>
+                <a:latin typeface="Aptos"/>
+              </a:rPr>
+              <a:t>Orchestrate the agents</a:t>
+            </a:r>
+          </a:p>
+          <a:p>
+            <a:r>
+              <a:rPr sz="1700">
+                <a:solidFill>
+                  <a:srgbClr val="455166"/>
+                </a:solidFill>
+                <a:latin typeface="Aptos"/>
+              </a:rPr>
+              <a:t>Quiz Master, Pixel Jam, TDD, hooks, logs, and UX review.</a:t>
+            </a:r>
+          </a:p>
+        </p:txBody>
+      </p:sp>
+      <p:sp>
+        <p:nvSpPr>
+          <p:cNvPr id="13" name="TextBox 13"/>
+          <p:cNvSpPr txBox="1"/>
+          <p:nvPr/>
+        </p:nvSpPr>
+        <p:spPr>
+          <a:xfrm>
+            <a:off x="685800" y="2465832"/>
+            <a:ext cx="594360" cy="320040"/>
+          </a:xfrm>
+          <a:prstGeom prst="rect">
+            <a:avLst/>
+          </a:prstGeom>
+        </p:spPr>
+        <p:txBody>
+          <a:bodyPr wrap="square" rtlCol="0">
+            <a:spAutoFit/>
+          </a:bodyPr>
+          <a:lstStyle/>
+          <a:p>
+            <a:r>
+              <a:rPr b="1" sz="1700" spc="60">
+                <a:solidFill>
+                  <a:srgbClr val="1746D1"/>
+                </a:solidFill>
+                <a:latin typeface="Aptos"/>
+              </a:rPr>
+              <a:t>01</a:t>
+            </a:r>
+          </a:p>
+        </p:txBody>
+      </p:sp>
+      <p:sp>
+        <p:nvSpPr>
+          <p:cNvPr id="14" name="TextBox 14"/>
+          <p:cNvSpPr txBox="1"/>
+          <p:nvPr/>
+        </p:nvSpPr>
+        <p:spPr>
+          <a:xfrm>
+            <a:off x="685800" y="3288792"/>
+            <a:ext cx="594360" cy="320040"/>
+          </a:xfrm>
+          <a:prstGeom prst="rect">
+            <a:avLst/>
+          </a:prstGeom>
+        </p:spPr>
+        <p:txBody>
+          <a:bodyPr wrap="square" rtlCol="0">
+            <a:spAutoFit/>
+          </a:bodyPr>
+          <a:lstStyle/>
+          <a:p>
+            <a:r>
+              <a:rPr b="1" sz="1700" spc="60">
+                <a:solidFill>
+                  <a:srgbClr val="1746D1"/>
+                </a:solidFill>
+                <a:latin typeface="Aptos"/>
+              </a:rPr>
+              <a:t>02</a:t>
+            </a:r>
+          </a:p>
+        </p:txBody>
+      </p:sp>
+      <p:sp>
+        <p:nvSpPr>
+          <p:cNvPr id="15" name="TextBox 15"/>
+          <p:cNvSpPr txBox="1"/>
+          <p:nvPr/>
+        </p:nvSpPr>
+        <p:spPr>
+          <a:xfrm>
+            <a:off x="685800" y="4111752"/>
+            <a:ext cx="594360" cy="320040"/>
+          </a:xfrm>
+          <a:prstGeom prst="rect">
+            <a:avLst/>
+          </a:prstGeom>
+        </p:spPr>
+        <p:txBody>
+          <a:bodyPr wrap="square" rtlCol="0">
+            <a:spAutoFit/>
+          </a:bodyPr>
+          <a:lstStyle/>
+          <a:p>
+            <a:r>
+              <a:rPr b="1" sz="1700" spc="60">
+                <a:solidFill>
+                  <a:srgbClr val="1746D1"/>
+                </a:solidFill>
+                <a:latin typeface="Aptos"/>
+              </a:rPr>
+              <a:t>03</a:t>
+            </a:r>
+          </a:p>
+        </p:txBody>
+      </p:sp>
+      <p:sp>
+        <p:nvSpPr>
+          <p:cNvPr id="16" name="Shape 16"/>
+          <p:cNvSpPr/>
+          <p:nvPr/>
+        </p:nvSpPr>
+        <p:spPr>
+          <a:xfrm>
+            <a:off x="685800" y="3063240"/>
+            <a:ext cx="7772400" cy="12700"/>
+          </a:xfrm>
+          <a:prstGeom prst="rect">
+            <a:avLst/>
+          </a:prstGeom>
+          <a:solidFill>
+            <a:srgbClr val="CFD8E8"/>
+          </a:solidFill>
+          <a:ln>
+            <a:noFill/>
+          </a:ln>
+        </p:spPr>
+        <p:txBody>
+          <a:bodyPr rtlCol="0" anchor="ctr"/>
+          <a:lstStyle/>
+          <a:p/>
+        </p:txBody>
+      </p:sp>
+      <p:sp>
+        <p:nvSpPr>
+          <p:cNvPr id="17" name="Shape 17"/>
+          <p:cNvSpPr/>
+          <p:nvPr/>
+        </p:nvSpPr>
+        <p:spPr>
+          <a:xfrm>
+            <a:off x="685800" y="3886200"/>
+            <a:ext cx="7772400" cy="12700"/>
+          </a:xfrm>
+          <a:prstGeom prst="rect">
+            <a:avLst/>
+          </a:prstGeom>
+          <a:solidFill>
+            <a:srgbClr val="CFD8E8"/>
+          </a:solidFill>
+          <a:ln>
+            <a:noFill/>
+          </a:ln>
+        </p:spPr>
+        <p:txBody>
+          <a:bodyPr rtlCol="0" anchor="ctr"/>
+          <a:lstStyle/>
+          <a:p/>
+        </p:txBody>
+      </p:sp>
+      <p:sp>
+        <p:nvSpPr>
+          <p:cNvPr id="18" name="Shape 18"/>
+          <p:cNvSpPr/>
+          <p:nvPr/>
+        </p:nvSpPr>
+        <p:spPr>
+          <a:xfrm>
+            <a:off x="685800" y="2011680"/>
+            <a:ext cx="594360" cy="54864"/>
+          </a:xfrm>
+          <a:prstGeom prst="rect">
+            <a:avLst/>
+          </a:prstGeom>
+          <a:solidFill>
+            <a:srgbClr val="E45A3E"/>
+          </a:solidFill>
+          <a:ln>
+            <a:noFill/>
+          </a:ln>
+        </p:spPr>
+        <p:txBody>
+          <a:bodyPr rtlCol="0" anchor="ctr"/>
+          <a:lstStyle/>
+          <a:p/>
         </p:txBody>
       </p:sp>
     </p:spTree>

</xml_diff>